<commit_message>
Rework 016 statistical deck maturity
</commit_message>
<xml_diff>
--- a/tests/fixtures/presentations/statistical_method_group_meeting/visual_review_packet_source/statistical_method_group_meeting_benchmark.pptx
+++ b/tests/fixtures/presentations/statistical_method_group_meeting/visual_review_packet_source/statistical_method_group_meeting_benchmark.pptx
@@ -3088,7 +3088,7 @@
     <p:bg>
       <p:bgPr>
         <a:solidFill>
-          <a:srgbClr val="F7F7F9"/>
+          <a:srgbClr val="F1F2F4"/>
         </a:solidFill>
         <a:effectLst/>
       </p:bgPr>
@@ -3174,7 +3174,7 @@
               </a:defRPr>
             </a:pPr>
             <a:r>
-              <a:t>Why iid intervals fail with center correlation</a:t>
+              <a:t>Center correlation breaks iid intervals</a:t>
             </a:r>
           </a:p>
         </p:txBody>
@@ -3246,7 +3246,7 @@
               </a:defRPr>
             </a:pPr>
             <a:r>
-              <a:t>The estimand is stable, but the uncertainty model changes.</a:t>
+              <a:t>The point estimate targets β₁, but the uncertainty model changes.</a:t>
             </a:r>
           </a:p>
         </p:txBody>
@@ -3259,7 +3259,7 @@
         </p:nvSpPr>
         <p:spPr>
           <a:xfrm>
-            <a:off x="749808" y="1078992"/>
+            <a:off x="749808" y="1060704"/>
             <a:ext cx="10789920" cy="237744"/>
           </a:xfrm>
           <a:prstGeom prst="rect">
@@ -3274,7 +3274,187 @@
           <a:lstStyle/>
           <a:p>
             <a:pPr algn="l">
-              <a:defRPr sz="1060" b="1">
+              <a:defRPr sz="1120" b="1">
+                <a:solidFill>
+                  <a:srgbClr val="606977"/>
+                </a:solidFill>
+                <a:latin typeface="Aptos"/>
+              </a:defRPr>
+            </a:pPr>
+            <a:r>
+              <a:t>Synthetic multi-center simulation; treatment effect β₁=0.25.</a:t>
+            </a:r>
+          </a:p>
+        </p:txBody>
+      </p:sp>
+      <p:pic>
+        <p:nvPicPr>
+          <p:cNvPr id="7" name="Picture 6" descr="slide1_dgp.png"/>
+          <p:cNvPicPr>
+            <a:picLocks noChangeAspect="1"/>
+          </p:cNvPicPr>
+          <p:nvPr/>
+        </p:nvPicPr>
+        <p:blipFill>
+          <a:blip r:embed="rId2"/>
+          <a:stretch>
+            <a:fillRect/>
+          </a:stretch>
+        </p:blipFill>
+        <p:spPr>
+          <a:xfrm>
+            <a:off x="777240" y="1591056"/>
+            <a:ext cx="6537960" cy="811337"/>
+          </a:xfrm>
+          <a:prstGeom prst="rect">
+            <a:avLst/>
+          </a:prstGeom>
+        </p:spPr>
+      </p:pic>
+      <p:pic>
+        <p:nvPicPr>
+          <p:cNvPr id="8" name="Picture 7" descr="slide1_components.png"/>
+          <p:cNvPicPr>
+            <a:picLocks noChangeAspect="1"/>
+          </p:cNvPicPr>
+          <p:nvPr/>
+        </p:nvPicPr>
+        <p:blipFill>
+          <a:blip r:embed="rId3"/>
+          <a:stretch>
+            <a:fillRect/>
+          </a:stretch>
+        </p:blipFill>
+        <p:spPr>
+          <a:xfrm>
+            <a:off x="841248" y="2761488"/>
+            <a:ext cx="6263640" cy="678779"/>
+          </a:xfrm>
+          <a:prstGeom prst="rect">
+            <a:avLst/>
+          </a:prstGeom>
+        </p:spPr>
+      </p:pic>
+      <p:pic>
+        <p:nvPicPr>
+          <p:cNvPr id="9" name="Picture 8" descr="slide1_icc.png"/>
+          <p:cNvPicPr>
+            <a:picLocks noChangeAspect="1"/>
+          </p:cNvPicPr>
+          <p:nvPr/>
+        </p:nvPicPr>
+        <p:blipFill>
+          <a:blip r:embed="rId4"/>
+          <a:stretch>
+            <a:fillRect/>
+          </a:stretch>
+        </p:blipFill>
+        <p:spPr>
+          <a:xfrm>
+            <a:off x="7973568" y="1828800"/>
+            <a:ext cx="2240280" cy="1037167"/>
+          </a:xfrm>
+          <a:prstGeom prst="rect">
+            <a:avLst/>
+          </a:prstGeom>
+        </p:spPr>
+      </p:pic>
+      <p:sp>
+        <p:nvSpPr>
+          <p:cNvPr id="10" name="TextBox 9"/>
+          <p:cNvSpPr txBox="1"/>
+          <p:nvPr/>
+        </p:nvSpPr>
+        <p:spPr>
+          <a:xfrm>
+            <a:off x="896112" y="3767328"/>
+            <a:ext cx="2377440" cy="256032"/>
+          </a:xfrm>
+          <a:prstGeom prst="rect">
+            <a:avLst/>
+          </a:prstGeom>
+          <a:noFill/>
+        </p:spPr>
+        <p:txBody>
+          <a:bodyPr wrap="square" lIns="36576" rIns="36576" tIns="18288" bIns="18288">
+            <a:spAutoFit/>
+          </a:bodyPr>
+          <a:lstStyle/>
+          <a:p>
+            <a:pPr algn="l">
+              <a:defRPr sz="1320" b="1">
+                <a:solidFill>
+                  <a:srgbClr val="1F4E79"/>
+                </a:solidFill>
+                <a:latin typeface="Aptos"/>
+              </a:defRPr>
+            </a:pPr>
+            <a:r>
+              <a:t>β₁ is the treatment effect.</a:t>
+            </a:r>
+          </a:p>
+        </p:txBody>
+      </p:sp>
+      <p:sp>
+        <p:nvSpPr>
+          <p:cNvPr id="11" name="TextBox 10"/>
+          <p:cNvSpPr txBox="1"/>
+          <p:nvPr/>
+        </p:nvSpPr>
+        <p:spPr>
+          <a:xfrm>
+            <a:off x="3383280" y="3767328"/>
+            <a:ext cx="3063240" cy="320040"/>
+          </a:xfrm>
+          <a:prstGeom prst="rect">
+            <a:avLst/>
+          </a:prstGeom>
+          <a:noFill/>
+        </p:spPr>
+        <p:txBody>
+          <a:bodyPr wrap="square" lIns="36576" rIns="36576" tIns="18288" bIns="18288">
+            <a:spAutoFit/>
+          </a:bodyPr>
+          <a:lstStyle/>
+          <a:p>
+            <a:pPr algn="l">
+              <a:defRPr sz="1220" b="1">
+                <a:solidFill>
+                  <a:srgbClr val="0F766E"/>
+                </a:solidFill>
+                <a:latin typeface="Aptos"/>
+              </a:defRPr>
+            </a:pPr>
+            <a:r>
+              <a:t>uⱼ: center-level shift shared within center j.</a:t>
+            </a:r>
+          </a:p>
+        </p:txBody>
+      </p:sp>
+      <p:sp>
+        <p:nvSpPr>
+          <p:cNvPr id="12" name="TextBox 11"/>
+          <p:cNvSpPr txBox="1"/>
+          <p:nvPr/>
+        </p:nvSpPr>
+        <p:spPr>
+          <a:xfrm>
+            <a:off x="6537960" y="3767328"/>
+            <a:ext cx="2423160" cy="320040"/>
+          </a:xfrm>
+          <a:prstGeom prst="rect">
+            <a:avLst/>
+          </a:prstGeom>
+          <a:noFill/>
+        </p:spPr>
+        <p:txBody>
+          <a:bodyPr wrap="square" lIns="36576" rIns="36576" tIns="18288" bIns="18288">
+            <a:spAutoFit/>
+          </a:bodyPr>
+          <a:lstStyle/>
+          <a:p>
+            <a:pPr algn="l">
+              <a:defRPr sz="1220" b="1">
                 <a:solidFill>
                   <a:srgbClr val="9A6A16"/>
                 </a:solidFill>
@@ -3282,21 +3462,21 @@
               </a:defRPr>
             </a:pPr>
             <a:r>
-              <a:t>Synthetic benchmark evidence boundary: generated DGP only, not completed validation or clinical evidence.</a:t>
-            </a:r>
-          </a:p>
-        </p:txBody>
-      </p:sp>
-      <p:sp>
-        <p:nvSpPr>
-          <p:cNvPr id="7" name="TextBox 6"/>
+              <a:t>εᵢⱼ: individual residual noise.</a:t>
+            </a:r>
+          </a:p>
+        </p:txBody>
+      </p:sp>
+      <p:sp>
+        <p:nvSpPr>
+          <p:cNvPr id="13" name="TextBox 12"/>
           <p:cNvSpPr txBox="1"/>
           <p:nvPr/>
         </p:nvSpPr>
         <p:spPr>
           <a:xfrm>
-            <a:off x="841248" y="1444752"/>
-            <a:ext cx="1188720" cy="219456"/>
+            <a:off x="7818120" y="2788920"/>
+            <a:ext cx="2926080" cy="566928"/>
           </a:xfrm>
           <a:prstGeom prst="rect">
             <a:avLst/>
@@ -3310,7 +3490,114 @@
           <a:lstStyle/>
           <a:p>
             <a:pPr algn="l">
-              <a:defRPr sz="1300" b="1">
+              <a:defRPr sz="1240" b="1">
+                <a:solidFill>
+                  <a:srgbClr val="4F1F68"/>
+                </a:solidFill>
+                <a:latin typeface="Aptos"/>
+              </a:defRPr>
+            </a:pPr>
+            <a:r>
+              <a:t>ρ is the intraclass correlation; center j is the inference unit.</a:t>
+            </a:r>
+          </a:p>
+        </p:txBody>
+      </p:sp>
+      <p:cxnSp>
+        <p:nvCxnSpPr>
+          <p:cNvPr id="14" name="Connector 13"/>
+          <p:cNvCxnSpPr/>
+          <p:nvPr/>
+        </p:nvCxnSpPr>
+        <p:spPr>
+          <a:xfrm>
+            <a:off x="868680" y="4407408"/>
+            <a:ext cx="9875520" cy="0"/>
+          </a:xfrm>
+          <a:prstGeom prst="line">
+            <a:avLst/>
+          </a:prstGeom>
+          <a:ln w="12700">
+            <a:solidFill>
+              <a:srgbClr val="C6CCD6"/>
+            </a:solidFill>
+          </a:ln>
+        </p:spPr>
+        <p:style>
+          <a:lnRef idx="2">
+            <a:schemeClr val="accent1"/>
+          </a:lnRef>
+          <a:fillRef idx="0">
+            <a:schemeClr val="accent1"/>
+          </a:fillRef>
+          <a:effectRef idx="1">
+            <a:schemeClr val="accent1"/>
+          </a:effectRef>
+          <a:fontRef idx="minor">
+            <a:schemeClr val="tx1"/>
+          </a:fontRef>
+        </p:style>
+      </p:cxnSp>
+      <p:sp>
+        <p:nvSpPr>
+          <p:cNvPr id="15" name="TextBox 14"/>
+          <p:cNvSpPr txBox="1"/>
+          <p:nvPr/>
+        </p:nvSpPr>
+        <p:spPr>
+          <a:xfrm>
+            <a:off x="914400" y="4700016"/>
+            <a:ext cx="8138160" cy="438912"/>
+          </a:xfrm>
+          <a:prstGeom prst="rect">
+            <a:avLst/>
+          </a:prstGeom>
+          <a:noFill/>
+        </p:spPr>
+        <p:txBody>
+          <a:bodyPr wrap="square" lIns="36576" rIns="36576" tIns="18288" bIns="18288">
+            <a:spAutoFit/>
+          </a:bodyPr>
+          <a:lstStyle/>
+          <a:p>
+            <a:pPr algn="l">
+              <a:defRPr sz="1520" b="1">
+                <a:solidFill>
+                  <a:srgbClr val="17202A"/>
+                </a:solidFill>
+                <a:latin typeface="Aptos"/>
+              </a:defRPr>
+            </a:pPr>
+            <a:r>
+              <a:t>Point estimates can remain centered while iid intervals lose coverage.</a:t>
+            </a:r>
+          </a:p>
+        </p:txBody>
+      </p:sp>
+      <p:sp>
+        <p:nvSpPr>
+          <p:cNvPr id="16" name="TextBox 15"/>
+          <p:cNvSpPr txBox="1"/>
+          <p:nvPr/>
+        </p:nvSpPr>
+        <p:spPr>
+          <a:xfrm>
+            <a:off x="914400" y="5285232"/>
+            <a:ext cx="9966960" cy="292608"/>
+          </a:xfrm>
+          <a:prstGeom prst="rect">
+            <a:avLst/>
+          </a:prstGeom>
+          <a:noFill/>
+        </p:spPr>
+        <p:txBody>
+          <a:bodyPr wrap="square" lIns="36576" rIns="36576" tIns="18288" bIns="18288">
+            <a:spAutoFit/>
+          </a:bodyPr>
+          <a:lstStyle/>
+          <a:p>
+            <a:pPr algn="l">
+              <a:defRPr sz="1160" b="0">
                 <a:solidFill>
                   <a:srgbClr val="606977"/>
                 </a:solidFill>
@@ -3318,568 +3605,7 @@
               </a:defRPr>
             </a:pPr>
             <a:r>
-              <a:t>DGP</a:t>
-            </a:r>
-          </a:p>
-        </p:txBody>
-      </p:sp>
-      <p:sp>
-        <p:nvSpPr>
-          <p:cNvPr id="8" name="Rectangle 7"/>
-          <p:cNvSpPr/>
-          <p:nvPr/>
-        </p:nvSpPr>
-        <p:spPr>
-          <a:xfrm>
-            <a:off x="822960" y="1737360"/>
-            <a:ext cx="4663440" cy="1508760"/>
-          </a:xfrm>
-          <a:prstGeom prst="rect">
-            <a:avLst/>
-          </a:prstGeom>
-          <a:solidFill>
-            <a:srgbClr val="E5EEF8"/>
-          </a:solidFill>
-          <a:ln w="12700">
-            <a:solidFill>
-              <a:srgbClr val="C6CCD6"/>
-            </a:solidFill>
-          </a:ln>
-        </p:spPr>
-        <p:style>
-          <a:lnRef idx="1">
-            <a:schemeClr val="accent1"/>
-          </a:lnRef>
-          <a:fillRef idx="3">
-            <a:schemeClr val="accent1"/>
-          </a:fillRef>
-          <a:effectRef idx="2">
-            <a:schemeClr val="accent1"/>
-          </a:effectRef>
-          <a:fontRef idx="minor">
-            <a:schemeClr val="lt1"/>
-          </a:fontRef>
-        </p:style>
-        <p:txBody>
-          <a:bodyPr rtlCol="0" anchor="ctr"/>
-          <a:lstStyle/>
-          <a:p>
-            <a:pPr algn="ctr"/>
-          </a:p>
-        </p:txBody>
-      </p:sp>
-      <p:sp>
-        <p:nvSpPr>
-          <p:cNvPr id="9" name="TextBox 8"/>
-          <p:cNvSpPr txBox="1"/>
-          <p:nvPr/>
-        </p:nvSpPr>
-        <p:spPr>
-          <a:xfrm>
-            <a:off x="877824" y="1783080"/>
-            <a:ext cx="4553712" cy="1417319"/>
-          </a:xfrm>
-          <a:prstGeom prst="rect">
-            <a:avLst/>
-          </a:prstGeom>
-          <a:noFill/>
-        </p:spPr>
-        <p:txBody>
-          <a:bodyPr wrap="square" lIns="36576" rIns="36576" tIns="18288" bIns="18288">
-            <a:spAutoFit/>
-          </a:bodyPr>
-          <a:lstStyle/>
-          <a:p>
-            <a:pPr algn="ctr">
-              <a:defRPr sz="1700" b="1">
-                <a:solidFill>
-                  <a:srgbClr val="1F4E79"/>
-                </a:solidFill>
-                <a:latin typeface="Aptos"/>
-              </a:defRPr>
-            </a:pPr>
-            <a:r>
-              <a:t>Y_ij = beta_0 + beta_1 T_ij + u_j + epsilon_ij</a:t>
-            </a:r>
-            <a:br/>
-            <a:br/>
-            <a:r>
-              <a:t>Estimand: beta_1 = treatment effect</a:t>
-            </a:r>
-          </a:p>
-        </p:txBody>
-      </p:sp>
-      <p:sp>
-        <p:nvSpPr>
-          <p:cNvPr id="10" name="Rectangle 9"/>
-          <p:cNvSpPr/>
-          <p:nvPr/>
-        </p:nvSpPr>
-        <p:spPr>
-          <a:xfrm>
-            <a:off x="5870448" y="1508760"/>
-            <a:ext cx="2423160" cy="1143000"/>
-          </a:xfrm>
-          <a:prstGeom prst="rect">
-            <a:avLst/>
-          </a:prstGeom>
-          <a:solidFill>
-            <a:srgbClr val="E1F4F1"/>
-          </a:solidFill>
-          <a:ln w="12700">
-            <a:solidFill>
-              <a:srgbClr val="C6CCD6"/>
-            </a:solidFill>
-          </a:ln>
-        </p:spPr>
-        <p:style>
-          <a:lnRef idx="1">
-            <a:schemeClr val="accent1"/>
-          </a:lnRef>
-          <a:fillRef idx="3">
-            <a:schemeClr val="accent1"/>
-          </a:fillRef>
-          <a:effectRef idx="2">
-            <a:schemeClr val="accent1"/>
-          </a:effectRef>
-          <a:fontRef idx="minor">
-            <a:schemeClr val="lt1"/>
-          </a:fontRef>
-        </p:style>
-        <p:txBody>
-          <a:bodyPr rtlCol="0" anchor="ctr"/>
-          <a:lstStyle/>
-          <a:p>
-            <a:pPr algn="ctr"/>
-          </a:p>
-        </p:txBody>
-      </p:sp>
-      <p:sp>
-        <p:nvSpPr>
-          <p:cNvPr id="11" name="TextBox 10"/>
-          <p:cNvSpPr txBox="1"/>
-          <p:nvPr/>
-        </p:nvSpPr>
-        <p:spPr>
-          <a:xfrm>
-            <a:off x="5925312" y="1554480"/>
-            <a:ext cx="2313432" cy="1051560"/>
-          </a:xfrm>
-          <a:prstGeom prst="rect">
-            <a:avLst/>
-          </a:prstGeom>
-          <a:noFill/>
-        </p:spPr>
-        <p:txBody>
-          <a:bodyPr wrap="square" lIns="36576" rIns="36576" tIns="18288" bIns="18288">
-            <a:spAutoFit/>
-          </a:bodyPr>
-          <a:lstStyle/>
-          <a:p>
-            <a:pPr algn="ctr">
-              <a:defRPr sz="1260" b="1">
-                <a:solidFill>
-                  <a:srgbClr val="0F766E"/>
-                </a:solidFill>
-                <a:latin typeface="Aptos"/>
-              </a:defRPr>
-            </a:pPr>
-            <a:r>
-              <a:t>u_j ~ N(0, tau^2)</a:t>
-            </a:r>
-            <a:br/>
-            <a:r>
-              <a:t>center-level random effect</a:t>
-            </a:r>
-            <a:br/>
-            <a:r>
-              <a:t>shared inside center j</a:t>
-            </a:r>
-          </a:p>
-        </p:txBody>
-      </p:sp>
-      <p:sp>
-        <p:nvSpPr>
-          <p:cNvPr id="12" name="Rectangle 11"/>
-          <p:cNvSpPr/>
-          <p:nvPr/>
-        </p:nvSpPr>
-        <p:spPr>
-          <a:xfrm>
-            <a:off x="8732520" y="1508760"/>
-            <a:ext cx="2331720" cy="1143000"/>
-          </a:xfrm>
-          <a:prstGeom prst="rect">
-            <a:avLst/>
-          </a:prstGeom>
-          <a:solidFill>
-            <a:srgbClr val="FBF1D6"/>
-          </a:solidFill>
-          <a:ln w="12700">
-            <a:solidFill>
-              <a:srgbClr val="C6CCD6"/>
-            </a:solidFill>
-          </a:ln>
-        </p:spPr>
-        <p:style>
-          <a:lnRef idx="1">
-            <a:schemeClr val="accent1"/>
-          </a:lnRef>
-          <a:fillRef idx="3">
-            <a:schemeClr val="accent1"/>
-          </a:fillRef>
-          <a:effectRef idx="2">
-            <a:schemeClr val="accent1"/>
-          </a:effectRef>
-          <a:fontRef idx="minor">
-            <a:schemeClr val="lt1"/>
-          </a:fontRef>
-        </p:style>
-        <p:txBody>
-          <a:bodyPr rtlCol="0" anchor="ctr"/>
-          <a:lstStyle/>
-          <a:p>
-            <a:pPr algn="ctr"/>
-          </a:p>
-        </p:txBody>
-      </p:sp>
-      <p:sp>
-        <p:nvSpPr>
-          <p:cNvPr id="13" name="TextBox 12"/>
-          <p:cNvSpPr txBox="1"/>
-          <p:nvPr/>
-        </p:nvSpPr>
-        <p:spPr>
-          <a:xfrm>
-            <a:off x="8787384" y="1554480"/>
-            <a:ext cx="2221991" cy="1051560"/>
-          </a:xfrm>
-          <a:prstGeom prst="rect">
-            <a:avLst/>
-          </a:prstGeom>
-          <a:noFill/>
-        </p:spPr>
-        <p:txBody>
-          <a:bodyPr wrap="square" lIns="36576" rIns="36576" tIns="18288" bIns="18288">
-            <a:spAutoFit/>
-          </a:bodyPr>
-          <a:lstStyle/>
-          <a:p>
-            <a:pPr algn="ctr">
-              <a:defRPr sz="1260" b="1">
-                <a:solidFill>
-                  <a:srgbClr val="9A6A16"/>
-                </a:solidFill>
-                <a:latin typeface="Aptos"/>
-              </a:defRPr>
-            </a:pPr>
-            <a:r>
-              <a:t>epsilon_ij ~ N(0, sigma^2)</a:t>
-            </a:r>
-            <a:br/>
-            <a:r>
-              <a:t>individual residual noise</a:t>
-            </a:r>
-          </a:p>
-        </p:txBody>
-      </p:sp>
-      <p:sp>
-        <p:nvSpPr>
-          <p:cNvPr id="14" name="Rectangle 13"/>
-          <p:cNvSpPr/>
-          <p:nvPr/>
-        </p:nvSpPr>
-        <p:spPr>
-          <a:xfrm>
-            <a:off x="6080760" y="2999232"/>
-            <a:ext cx="4800600" cy="841248"/>
-          </a:xfrm>
-          <a:prstGeom prst="rect">
-            <a:avLst/>
-          </a:prstGeom>
-          <a:solidFill>
-            <a:srgbClr val="F8E3E1"/>
-          </a:solidFill>
-          <a:ln w="12700">
-            <a:solidFill>
-              <a:srgbClr val="C6CCD6"/>
-            </a:solidFill>
-          </a:ln>
-        </p:spPr>
-        <p:style>
-          <a:lnRef idx="1">
-            <a:schemeClr val="accent1"/>
-          </a:lnRef>
-          <a:fillRef idx="3">
-            <a:schemeClr val="accent1"/>
-          </a:fillRef>
-          <a:effectRef idx="2">
-            <a:schemeClr val="accent1"/>
-          </a:effectRef>
-          <a:fontRef idx="minor">
-            <a:schemeClr val="lt1"/>
-          </a:fontRef>
-        </p:style>
-        <p:txBody>
-          <a:bodyPr rtlCol="0" anchor="ctr"/>
-          <a:lstStyle/>
-          <a:p>
-            <a:pPr algn="ctr"/>
-          </a:p>
-        </p:txBody>
-      </p:sp>
-      <p:sp>
-        <p:nvSpPr>
-          <p:cNvPr id="15" name="TextBox 14"/>
-          <p:cNvSpPr txBox="1"/>
-          <p:nvPr/>
-        </p:nvSpPr>
-        <p:spPr>
-          <a:xfrm>
-            <a:off x="6135624" y="3044951"/>
-            <a:ext cx="4690872" cy="749808"/>
-          </a:xfrm>
-          <a:prstGeom prst="rect">
-            <a:avLst/>
-          </a:prstGeom>
-          <a:noFill/>
-        </p:spPr>
-        <p:txBody>
-          <a:bodyPr wrap="square" lIns="36576" rIns="36576" tIns="18288" bIns="18288">
-            <a:spAutoFit/>
-          </a:bodyPr>
-          <a:lstStyle/>
-          <a:p>
-            <a:pPr algn="ctr">
-              <a:defRPr sz="1300" b="1">
-                <a:solidFill>
-                  <a:srgbClr val="A33A34"/>
-                </a:solidFill>
-                <a:latin typeface="Aptos"/>
-              </a:defRPr>
-            </a:pPr>
-            <a:r>
-              <a:t>ICC rho = tau^2 / (tau^2 + sigma^2)</a:t>
-            </a:r>
-            <a:br/>
-            <a:r>
-              <a:t>center is the correlation and inference unit</a:t>
-            </a:r>
-          </a:p>
-        </p:txBody>
-      </p:sp>
-      <p:cxnSp>
-        <p:nvCxnSpPr>
-          <p:cNvPr id="16" name="Connector 15"/>
-          <p:cNvCxnSpPr/>
-          <p:nvPr/>
-        </p:nvCxnSpPr>
-        <p:spPr>
-          <a:xfrm flipV="1">
-            <a:off x="5486400" y="2084831"/>
-            <a:ext cx="347472" cy="384049"/>
-          </a:xfrm>
-          <a:prstGeom prst="line">
-            <a:avLst/>
-          </a:prstGeom>
-          <a:ln w="21590">
-            <a:solidFill>
-              <a:srgbClr val="4F1F68"/>
-            </a:solidFill>
-            <a:tailEnd type="triangle"/>
-          </a:ln>
-        </p:spPr>
-        <p:style>
-          <a:lnRef idx="2">
-            <a:schemeClr val="accent1"/>
-          </a:lnRef>
-          <a:fillRef idx="0">
-            <a:schemeClr val="accent1"/>
-          </a:fillRef>
-          <a:effectRef idx="1">
-            <a:schemeClr val="accent1"/>
-          </a:effectRef>
-          <a:fontRef idx="minor">
-            <a:schemeClr val="tx1"/>
-          </a:fontRef>
-        </p:style>
-      </p:cxnSp>
-      <p:cxnSp>
-        <p:nvCxnSpPr>
-          <p:cNvPr id="17" name="Connector 16"/>
-          <p:cNvCxnSpPr/>
-          <p:nvPr/>
-        </p:nvCxnSpPr>
-        <p:spPr>
-          <a:xfrm>
-            <a:off x="8302752" y="2084831"/>
-            <a:ext cx="384048" cy="0"/>
-          </a:xfrm>
-          <a:prstGeom prst="line">
-            <a:avLst/>
-          </a:prstGeom>
-          <a:ln w="21590">
-            <a:solidFill>
-              <a:srgbClr val="4F1F68"/>
-            </a:solidFill>
-            <a:tailEnd type="triangle"/>
-          </a:ln>
-        </p:spPr>
-        <p:style>
-          <a:lnRef idx="2">
-            <a:schemeClr val="accent1"/>
-          </a:lnRef>
-          <a:fillRef idx="0">
-            <a:schemeClr val="accent1"/>
-          </a:fillRef>
-          <a:effectRef idx="1">
-            <a:schemeClr val="accent1"/>
-          </a:effectRef>
-          <a:fontRef idx="minor">
-            <a:schemeClr val="tx1"/>
-          </a:fontRef>
-        </p:style>
-      </p:cxnSp>
-      <p:cxnSp>
-        <p:nvCxnSpPr>
-          <p:cNvPr id="18" name="Connector 17"/>
-          <p:cNvCxnSpPr/>
-          <p:nvPr/>
-        </p:nvCxnSpPr>
-        <p:spPr>
-          <a:xfrm>
-            <a:off x="7955279" y="2788920"/>
-            <a:ext cx="0" cy="182880"/>
-          </a:xfrm>
-          <a:prstGeom prst="line">
-            <a:avLst/>
-          </a:prstGeom>
-          <a:ln w="21590">
-            <a:solidFill>
-              <a:srgbClr val="4F1F68"/>
-            </a:solidFill>
-            <a:tailEnd type="triangle"/>
-          </a:ln>
-        </p:spPr>
-        <p:style>
-          <a:lnRef idx="2">
-            <a:schemeClr val="accent1"/>
-          </a:lnRef>
-          <a:fillRef idx="0">
-            <a:schemeClr val="accent1"/>
-          </a:fillRef>
-          <a:effectRef idx="1">
-            <a:schemeClr val="accent1"/>
-          </a:effectRef>
-          <a:fontRef idx="minor">
-            <a:schemeClr val="tx1"/>
-          </a:fontRef>
-        </p:style>
-      </p:cxnSp>
-      <p:sp>
-        <p:nvSpPr>
-          <p:cNvPr id="19" name="TextBox 18"/>
-          <p:cNvSpPr txBox="1"/>
-          <p:nvPr/>
-        </p:nvSpPr>
-        <p:spPr>
-          <a:xfrm>
-            <a:off x="868680" y="4389120"/>
-            <a:ext cx="10058400" cy="438912"/>
-          </a:xfrm>
-          <a:prstGeom prst="rect">
-            <a:avLst/>
-          </a:prstGeom>
-          <a:noFill/>
-        </p:spPr>
-        <p:txBody>
-          <a:bodyPr wrap="square" lIns="36576" rIns="36576" tIns="18288" bIns="18288">
-            <a:spAutoFit/>
-          </a:bodyPr>
-          <a:lstStyle/>
-          <a:p>
-            <a:pPr algn="l">
-              <a:defRPr sz="1420" b="1">
-                <a:solidFill>
-                  <a:srgbClr val="17202A"/>
-                </a:solidFill>
-                <a:latin typeface="Aptos"/>
-              </a:defRPr>
-            </a:pPr>
-            <a:r>
-              <a:t>Why this page matters: point estimates can remain centered near beta_1 while interval coverage fails when residuals are correlated within center.</a:t>
-            </a:r>
-          </a:p>
-        </p:txBody>
-      </p:sp>
-      <p:sp>
-        <p:nvSpPr>
-          <p:cNvPr id="20" name="TextBox 19"/>
-          <p:cNvSpPr txBox="1"/>
-          <p:nvPr/>
-        </p:nvSpPr>
-        <p:spPr>
-          <a:xfrm>
-            <a:off x="868680" y="5102352"/>
-            <a:ext cx="10058400" cy="292608"/>
-          </a:xfrm>
-          <a:prstGeom prst="rect">
-            <a:avLst/>
-          </a:prstGeom>
-          <a:noFill/>
-        </p:spPr>
-        <p:txBody>
-          <a:bodyPr wrap="square" lIns="36576" rIns="36576" tIns="18288" bIns="18288">
-            <a:spAutoFit/>
-          </a:bodyPr>
-          <a:lstStyle/>
-          <a:p>
-            <a:pPr algn="l">
-              <a:defRPr sz="1120" b="0">
-                <a:solidFill>
-                  <a:srgbClr val="606977"/>
-                </a:solidFill>
-                <a:latin typeface="Aptos"/>
-              </a:defRPr>
-            </a:pPr>
-            <a:r>
-              <a:t>Simulation grid: G=[8, 20, 50], rho=[0.0, 0.1, 0.3, 0.5], imbalance=['balanced', 'imbalanced'], seed=20260822.</a:t>
-            </a:r>
-          </a:p>
-        </p:txBody>
-      </p:sp>
-      <p:sp>
-        <p:nvSpPr>
-          <p:cNvPr id="21" name="TextBox 20"/>
-          <p:cNvSpPr txBox="1"/>
-          <p:nvPr/>
-        </p:nvSpPr>
-        <p:spPr>
-          <a:xfrm>
-            <a:off x="868680" y="5989320"/>
-            <a:ext cx="10241280" cy="320040"/>
-          </a:xfrm>
-          <a:prstGeom prst="rect">
-            <a:avLst/>
-          </a:prstGeom>
-          <a:noFill/>
-        </p:spPr>
-        <p:txBody>
-          <a:bodyPr wrap="square" lIns="36576" rIns="36576" tIns="18288" bIns="18288">
-            <a:spAutoFit/>
-          </a:bodyPr>
-          <a:lstStyle/>
-          <a:p>
-            <a:pPr algn="l">
-              <a:defRPr sz="840" b="0">
-                <a:solidFill>
-                  <a:srgbClr val="606977"/>
-                </a:solidFill>
-                <a:latin typeface="Aptos"/>
-              </a:defRPr>
-            </a:pPr>
-            <a:r>
-              <a:t>Reference retrieval: statistical-model query selected inspected pages RRL-044, RRL-007, RRL-008, RRL-043, RRL-042; trace in EVIDENCE_MANIFEST; style not copied.</a:t>
+              <a:t>Grid: G=8/20/50 centers, ICC ρ=0/.1/.3/.5, balanced and imbalanced cluster sizes.</a:t>
             </a:r>
           </a:p>
         </p:txBody>
@@ -3898,7 +3624,7 @@
     <p:bg>
       <p:bgPr>
         <a:solidFill>
-          <a:srgbClr val="F7F7F9"/>
+          <a:srgbClr val="F1F2F4"/>
         </a:solidFill>
         <a:effectLst/>
       </p:bgPr>
@@ -3984,7 +3710,7 @@
               </a:defRPr>
             </a:pPr>
             <a:r>
-              <a:t>Cluster sandwich changes the variance object</a:t>
+              <a:t>The sandwich variance aggregates by center</a:t>
             </a:r>
           </a:p>
         </p:txBody>
@@ -4056,7 +3782,7 @@
               </a:defRPr>
             </a:pPr>
             <a:r>
-              <a:t>The center, not the row, becomes the covariance aggregation unit.</a:t>
+              <a:t>The middle term is a center-level score covariance, not a row-level residual pool.</a:t>
             </a:r>
           </a:p>
         </p:txBody>
@@ -4069,8 +3795,8 @@
         </p:nvSpPr>
         <p:spPr>
           <a:xfrm>
-            <a:off x="777240" y="1069848"/>
-            <a:ext cx="10515600" cy="237744"/>
+            <a:off x="777240" y="1060704"/>
+            <a:ext cx="10515600" cy="256032"/>
           </a:xfrm>
           <a:prstGeom prst="rect">
             <a:avLst/>
@@ -4084,297 +3810,61 @@
           <a:lstStyle/>
           <a:p>
             <a:pPr algn="l">
-              <a:defRPr sz="1100" b="1">
+              <a:defRPr sz="1180" b="1">
                 <a:solidFill>
-                  <a:srgbClr val="9A6A16"/>
+                  <a:srgbClr val="606977"/>
                 </a:solidFill>
                 <a:latin typeface="Aptos"/>
               </a:defRPr>
             </a:pPr>
             <a:r>
-              <a:t>Naive iid variance treats rows as independent; cluster sandwich groups score contributions by center.</a:t>
-            </a:r>
-          </a:p>
-        </p:txBody>
-      </p:sp>
-      <p:sp>
-        <p:nvSpPr>
-          <p:cNvPr id="7" name="Rectangle 6"/>
-          <p:cNvSpPr/>
-          <p:nvPr/>
-        </p:nvSpPr>
-        <p:spPr>
-          <a:xfrm>
-            <a:off x="822960" y="1508760"/>
-            <a:ext cx="2834640" cy="1170432"/>
-          </a:xfrm>
-          <a:prstGeom prst="rect">
-            <a:avLst/>
-          </a:prstGeom>
-          <a:solidFill>
-            <a:srgbClr val="F8E3E1"/>
-          </a:solidFill>
-          <a:ln w="12700">
-            <a:solidFill>
-              <a:srgbClr val="C6CCD6"/>
-            </a:solidFill>
-          </a:ln>
-        </p:spPr>
-        <p:style>
-          <a:lnRef idx="1">
-            <a:schemeClr val="accent1"/>
-          </a:lnRef>
-          <a:fillRef idx="3">
-            <a:schemeClr val="accent1"/>
-          </a:fillRef>
-          <a:effectRef idx="2">
-            <a:schemeClr val="accent1"/>
-          </a:effectRef>
-          <a:fontRef idx="minor">
-            <a:schemeClr val="lt1"/>
-          </a:fontRef>
-        </p:style>
-        <p:txBody>
-          <a:bodyPr rtlCol="0" anchor="ctr"/>
-          <a:lstStyle/>
-          <a:p>
-            <a:pPr algn="ctr"/>
-          </a:p>
-        </p:txBody>
-      </p:sp>
-      <p:sp>
-        <p:nvSpPr>
-          <p:cNvPr id="8" name="TextBox 7"/>
-          <p:cNvSpPr txBox="1"/>
-          <p:nvPr/>
-        </p:nvSpPr>
-        <p:spPr>
-          <a:xfrm>
-            <a:off x="877824" y="1554480"/>
-            <a:ext cx="2724912" cy="1078992"/>
-          </a:xfrm>
-          <a:prstGeom prst="rect">
-            <a:avLst/>
-          </a:prstGeom>
-          <a:noFill/>
-        </p:spPr>
-        <p:txBody>
-          <a:bodyPr wrap="square" lIns="36576" rIns="36576" tIns="18288" bIns="18288">
-            <a:spAutoFit/>
-          </a:bodyPr>
-          <a:lstStyle/>
-          <a:p>
-            <a:pPr algn="ctr">
-              <a:defRPr sz="1230" b="1">
-                <a:solidFill>
-                  <a:srgbClr val="A33A34"/>
-                </a:solidFill>
-                <a:latin typeface="Aptos"/>
-              </a:defRPr>
-            </a:pPr>
-            <a:r>
-              <a:t>Naive iid OLS interval</a:t>
-            </a:r>
-            <a:br/>
-            <a:r>
-              <a:t>Var(beta_hat) = sigma_hat^2 (X'X)^(-1)</a:t>
-            </a:r>
-            <a:br/>
-            <a:r>
-              <a:t>row residuals are pooled one by one</a:t>
-            </a:r>
-          </a:p>
-        </p:txBody>
-      </p:sp>
-      <p:sp>
-        <p:nvSpPr>
-          <p:cNvPr id="9" name="Rectangle 8"/>
-          <p:cNvSpPr/>
-          <p:nvPr/>
-        </p:nvSpPr>
-        <p:spPr>
-          <a:xfrm>
-            <a:off x="2971800" y="2468880"/>
-            <a:ext cx="6355080" cy="713232"/>
-          </a:xfrm>
-          <a:prstGeom prst="rect">
-            <a:avLst/>
-          </a:prstGeom>
-          <a:solidFill>
-            <a:srgbClr val="E5EEF8"/>
-          </a:solidFill>
-          <a:ln w="12700">
-            <a:solidFill>
-              <a:srgbClr val="C6CCD6"/>
-            </a:solidFill>
-          </a:ln>
-        </p:spPr>
-        <p:style>
-          <a:lnRef idx="1">
-            <a:schemeClr val="accent1"/>
-          </a:lnRef>
-          <a:fillRef idx="3">
-            <a:schemeClr val="accent1"/>
-          </a:fillRef>
-          <a:effectRef idx="2">
-            <a:schemeClr val="accent1"/>
-          </a:effectRef>
-          <a:fontRef idx="minor">
-            <a:schemeClr val="lt1"/>
-          </a:fontRef>
-        </p:style>
-        <p:txBody>
-          <a:bodyPr rtlCol="0" anchor="ctr"/>
-          <a:lstStyle/>
-          <a:p>
-            <a:pPr algn="ctr"/>
-          </a:p>
-        </p:txBody>
-      </p:sp>
-      <p:sp>
-        <p:nvSpPr>
-          <p:cNvPr id="10" name="TextBox 9"/>
-          <p:cNvSpPr txBox="1"/>
-          <p:nvPr/>
-        </p:nvSpPr>
-        <p:spPr>
-          <a:xfrm>
-            <a:off x="3026664" y="2514600"/>
-            <a:ext cx="6245352" cy="621792"/>
-          </a:xfrm>
-          <a:prstGeom prst="rect">
-            <a:avLst/>
-          </a:prstGeom>
-          <a:noFill/>
-        </p:spPr>
-        <p:txBody>
-          <a:bodyPr wrap="square" lIns="36576" rIns="36576" tIns="18288" bIns="18288">
-            <a:spAutoFit/>
-          </a:bodyPr>
-          <a:lstStyle/>
-          <a:p>
-            <a:pPr algn="ctr">
-              <a:defRPr sz="1650" b="1">
-                <a:solidFill>
-                  <a:srgbClr val="1F4E79"/>
-                </a:solidFill>
-                <a:latin typeface="Aptos"/>
-              </a:defRPr>
-            </a:pPr>
-            <a:r>
-              <a:t>V_CR = (X'X)^(-1) [ sum_g X_g' u_g u_g' X_g ] (X'X)^(-1)</a:t>
-            </a:r>
-          </a:p>
-        </p:txBody>
-      </p:sp>
-      <p:sp>
-        <p:nvSpPr>
-          <p:cNvPr id="11" name="Rectangle 10"/>
-          <p:cNvSpPr/>
-          <p:nvPr/>
-        </p:nvSpPr>
-        <p:spPr>
-          <a:xfrm>
-            <a:off x="9555480" y="1508760"/>
-            <a:ext cx="1874519" cy="1170432"/>
-          </a:xfrm>
-          <a:prstGeom prst="rect">
-            <a:avLst/>
-          </a:prstGeom>
-          <a:solidFill>
-            <a:srgbClr val="E1F4F1"/>
-          </a:solidFill>
-          <a:ln w="12700">
-            <a:solidFill>
-              <a:srgbClr val="C6CCD6"/>
-            </a:solidFill>
-          </a:ln>
-        </p:spPr>
-        <p:style>
-          <a:lnRef idx="1">
-            <a:schemeClr val="accent1"/>
-          </a:lnRef>
-          <a:fillRef idx="3">
-            <a:schemeClr val="accent1"/>
-          </a:fillRef>
-          <a:effectRef idx="2">
-            <a:schemeClr val="accent1"/>
-          </a:effectRef>
-          <a:fontRef idx="minor">
-            <a:schemeClr val="lt1"/>
-          </a:fontRef>
-        </p:style>
-        <p:txBody>
-          <a:bodyPr rtlCol="0" anchor="ctr"/>
-          <a:lstStyle/>
-          <a:p>
-            <a:pPr algn="ctr"/>
-          </a:p>
-        </p:txBody>
-      </p:sp>
-      <p:sp>
-        <p:nvSpPr>
-          <p:cNvPr id="12" name="TextBox 11"/>
-          <p:cNvSpPr txBox="1"/>
-          <p:nvPr/>
-        </p:nvSpPr>
-        <p:spPr>
-          <a:xfrm>
-            <a:off x="9610344" y="1554480"/>
-            <a:ext cx="1764791" cy="1078992"/>
-          </a:xfrm>
-          <a:prstGeom prst="rect">
-            <a:avLst/>
-          </a:prstGeom>
-          <a:noFill/>
-        </p:spPr>
-        <p:txBody>
-          <a:bodyPr wrap="square" lIns="36576" rIns="36576" tIns="18288" bIns="18288">
-            <a:spAutoFit/>
-          </a:bodyPr>
-          <a:lstStyle/>
-          <a:p>
-            <a:pPr algn="ctr">
-              <a:defRPr sz="1120" b="1">
-                <a:solidFill>
-                  <a:srgbClr val="0F766E"/>
-                </a:solidFill>
-                <a:latin typeface="Aptos"/>
-              </a:defRPr>
-            </a:pPr>
-            <a:r>
-              <a:t>Center g block</a:t>
-            </a:r>
-            <a:br/>
-            <a:r>
-              <a:t>X_g rows + residual vector u_g</a:t>
-            </a:r>
-            <a:br/>
-            <a:r>
-              <a:t>aggregated before variance</a:t>
-            </a:r>
-          </a:p>
-        </p:txBody>
-      </p:sp>
+              <a:t>Both intervals estimate β₁; only the variance object changes.</a:t>
+            </a:r>
+          </a:p>
+        </p:txBody>
+      </p:sp>
+      <p:pic>
+        <p:nvPicPr>
+          <p:cNvPr id="7" name="Picture 6" descr="slide2_sandwich.png"/>
+          <p:cNvPicPr>
+            <a:picLocks noChangeAspect="1"/>
+          </p:cNvPicPr>
+          <p:nvPr/>
+        </p:nvPicPr>
+        <p:blipFill>
+          <a:blip r:embed="rId2"/>
+          <a:stretch>
+            <a:fillRect/>
+          </a:stretch>
+        </p:blipFill>
+        <p:spPr>
+          <a:xfrm>
+            <a:off x="694944" y="1627632"/>
+            <a:ext cx="9235440" cy="1251367"/>
+          </a:xfrm>
+          <a:prstGeom prst="rect">
+            <a:avLst/>
+          </a:prstGeom>
+        </p:spPr>
+      </p:pic>
       <p:cxnSp>
         <p:nvCxnSpPr>
-          <p:cNvPr id="13" name="Connector 12"/>
+          <p:cNvPr id="8" name="Connector 7"/>
           <p:cNvCxnSpPr/>
           <p:nvPr/>
         </p:nvCxnSpPr>
         <p:spPr>
           <a:xfrm>
-            <a:off x="3657600" y="2084831"/>
-            <a:ext cx="914400" cy="338329"/>
+            <a:off x="4709160" y="2743200"/>
+            <a:ext cx="2130552" cy="0"/>
           </a:xfrm>
           <a:prstGeom prst="line">
             <a:avLst/>
           </a:prstGeom>
-          <a:ln w="21590">
+          <a:ln w="38100">
             <a:solidFill>
               <a:srgbClr val="4F1F68"/>
             </a:solidFill>
-            <a:tailEnd type="triangle"/>
           </a:ln>
         </p:spPr>
         <p:style>
@@ -4394,19 +3884,19 @@
       </p:cxnSp>
       <p:cxnSp>
         <p:nvCxnSpPr>
-          <p:cNvPr id="14" name="Connector 13"/>
+          <p:cNvPr id="9" name="Connector 8"/>
           <p:cNvCxnSpPr/>
           <p:nvPr/>
         </p:nvCxnSpPr>
         <p:spPr>
-          <a:xfrm flipH="1">
-            <a:off x="8641080" y="2103120"/>
-            <a:ext cx="868680" cy="320040"/>
+          <a:xfrm>
+            <a:off x="5897880" y="2816352"/>
+            <a:ext cx="0" cy="585216"/>
           </a:xfrm>
           <a:prstGeom prst="line">
             <a:avLst/>
           </a:prstGeom>
-          <a:ln w="21590">
+          <a:ln w="22860">
             <a:solidFill>
               <a:srgbClr val="4F1F68"/>
             </a:solidFill>
@@ -4430,14 +3920,14 @@
       </p:cxnSp>
       <p:sp>
         <p:nvSpPr>
-          <p:cNvPr id="15" name="TextBox 14"/>
+          <p:cNvPr id="10" name="TextBox 9"/>
           <p:cNvSpPr txBox="1"/>
           <p:nvPr/>
         </p:nvSpPr>
         <p:spPr>
           <a:xfrm>
-            <a:off x="914400" y="3822191"/>
-            <a:ext cx="10149840" cy="512064"/>
+            <a:off x="3794760" y="3529584"/>
+            <a:ext cx="4480560" cy="420624"/>
           </a:xfrm>
           <a:prstGeom prst="rect">
             <a:avLst/>
@@ -4450,8 +3940,104 @@
           </a:bodyPr>
           <a:lstStyle/>
           <a:p>
+            <a:pPr algn="ctr">
+              <a:defRPr sz="1300" b="1">
+                <a:solidFill>
+                  <a:srgbClr val="4F1F68"/>
+                </a:solidFill>
+                <a:latin typeface="Aptos"/>
+              </a:defRPr>
+            </a:pPr>
+            <a:r>
+              <a:t>Cluster meat: score contributions are summed by center before forming covariance.</a:t>
+            </a:r>
+          </a:p>
+        </p:txBody>
+      </p:sp>
+      <p:pic>
+        <p:nvPicPr>
+          <p:cNvPr id="11" name="Picture 10" descr="slide2_naive.png"/>
+          <p:cNvPicPr>
+            <a:picLocks noChangeAspect="1"/>
+          </p:cNvPicPr>
+          <p:nvPr/>
+        </p:nvPicPr>
+        <p:blipFill>
+          <a:blip r:embed="rId3"/>
+          <a:stretch>
+            <a:fillRect/>
+          </a:stretch>
+        </p:blipFill>
+        <p:spPr>
+          <a:xfrm>
+            <a:off x="896112" y="4553712"/>
+            <a:ext cx="2926080" cy="551878"/>
+          </a:xfrm>
+          <a:prstGeom prst="rect">
+            <a:avLst/>
+          </a:prstGeom>
+        </p:spPr>
+      </p:pic>
+      <p:sp>
+        <p:nvSpPr>
+          <p:cNvPr id="12" name="TextBox 11"/>
+          <p:cNvSpPr txBox="1"/>
+          <p:nvPr/>
+        </p:nvSpPr>
+        <p:spPr>
+          <a:xfrm>
+            <a:off x="960120" y="5266944"/>
+            <a:ext cx="3383280" cy="237744"/>
+          </a:xfrm>
+          <a:prstGeom prst="rect">
+            <a:avLst/>
+          </a:prstGeom>
+          <a:noFill/>
+        </p:spPr>
+        <p:txBody>
+          <a:bodyPr wrap="square" lIns="36576" rIns="36576" tIns="18288" bIns="18288">
+            <a:spAutoFit/>
+          </a:bodyPr>
+          <a:lstStyle/>
+          <a:p>
             <a:pPr algn="l">
-              <a:defRPr sz="1320" b="1">
+              <a:defRPr sz="1160" b="1">
+                <a:solidFill>
+                  <a:srgbClr val="A33A34"/>
+                </a:solidFill>
+                <a:latin typeface="Aptos"/>
+              </a:defRPr>
+            </a:pPr>
+            <a:r>
+              <a:t>Naive variance treats rows as independent.</a:t>
+            </a:r>
+          </a:p>
+        </p:txBody>
+      </p:sp>
+      <p:sp>
+        <p:nvSpPr>
+          <p:cNvPr id="13" name="TextBox 12"/>
+          <p:cNvSpPr txBox="1"/>
+          <p:nvPr/>
+        </p:nvSpPr>
+        <p:spPr>
+          <a:xfrm>
+            <a:off x="4828032" y="4599432"/>
+            <a:ext cx="5989320" cy="530352"/>
+          </a:xfrm>
+          <a:prstGeom prst="rect">
+            <a:avLst/>
+          </a:prstGeom>
+          <a:noFill/>
+        </p:spPr>
+        <p:txBody>
+          <a:bodyPr wrap="square" lIns="36576" rIns="36576" tIns="18288" bIns="18288">
+            <a:spAutoFit/>
+          </a:bodyPr>
+          <a:lstStyle/>
+          <a:p>
+            <a:pPr algn="l">
+              <a:defRPr sz="1340" b="1">
                 <a:solidFill>
                   <a:srgbClr val="17202A"/>
                 </a:solidFill>
@@ -4459,79 +4045,7 @@
               </a:defRPr>
             </a:pPr>
             <a:r>
-              <a:t>Key change: the middle term preserves within-center covariance in the score. The current benchmark uses cluster-robust z intervals; small-G correction is reserved for the planned next experiment.</a:t>
-            </a:r>
-          </a:p>
-        </p:txBody>
-      </p:sp>
-      <p:sp>
-        <p:nvSpPr>
-          <p:cNvPr id="16" name="TextBox 15"/>
-          <p:cNvSpPr txBox="1"/>
-          <p:nvPr/>
-        </p:nvSpPr>
-        <p:spPr>
-          <a:xfrm>
-            <a:off x="914400" y="4709160"/>
-            <a:ext cx="10149840" cy="310896"/>
-          </a:xfrm>
-          <a:prstGeom prst="rect">
-            <a:avLst/>
-          </a:prstGeom>
-          <a:noFill/>
-        </p:spPr>
-        <p:txBody>
-          <a:bodyPr wrap="square" lIns="36576" rIns="36576" tIns="18288" bIns="18288">
-            <a:spAutoFit/>
-          </a:bodyPr>
-          <a:lstStyle/>
-          <a:p>
-            <a:pPr algn="l">
-              <a:defRPr sz="1130" b="0">
-                <a:solidFill>
-                  <a:srgbClr val="606977"/>
-                </a:solidFill>
-                <a:latin typeface="Aptos"/>
-              </a:defRPr>
-            </a:pPr>
-            <a:r>
-              <a:t>Synthetic method labels: naive_iid_ols_z versus cluster_robust_z. Both estimate the same beta_1; only the interval variance changes.</a:t>
-            </a:r>
-          </a:p>
-        </p:txBody>
-      </p:sp>
-      <p:sp>
-        <p:nvSpPr>
-          <p:cNvPr id="17" name="TextBox 16"/>
-          <p:cNvSpPr txBox="1"/>
-          <p:nvPr/>
-        </p:nvSpPr>
-        <p:spPr>
-          <a:xfrm>
-            <a:off x="868680" y="5989320"/>
-            <a:ext cx="10241280" cy="320040"/>
-          </a:xfrm>
-          <a:prstGeom prst="rect">
-            <a:avLst/>
-          </a:prstGeom>
-          <a:noFill/>
-        </p:spPr>
-        <p:txBody>
-          <a:bodyPr wrap="square" lIns="36576" rIns="36576" tIns="18288" bIns="18288">
-            <a:spAutoFit/>
-          </a:bodyPr>
-          <a:lstStyle/>
-          <a:p>
-            <a:pPr algn="l">
-              <a:defRPr sz="840" b="0">
-                <a:solidFill>
-                  <a:srgbClr val="606977"/>
-                </a:solidFill>
-                <a:latin typeface="Aptos"/>
-              </a:defRPr>
-            </a:pPr>
-            <a:r>
-              <a:t>Reference retrieval: estimator/variance query selected inspected pages RRL-040, RRL-009, RRL-028, RRL-030, RRL-015; trace in EVIDENCE_MANIFEST; style not copied.</a:t>
+              <a:t>The simulation uses cluster-robust z intervals; CR2 and wild bootstrap remain planned comparisons.</a:t>
             </a:r>
           </a:p>
         </p:txBody>
@@ -4550,7 +4064,7 @@
     <p:bg>
       <p:bgPr>
         <a:solidFill>
-          <a:srgbClr val="F7F7F9"/>
+          <a:srgbClr val="F1F2F4"/>
         </a:solidFill>
         <a:effectLst/>
       </p:bgPr>
@@ -4636,7 +4150,7 @@
               </a:defRPr>
             </a:pPr>
             <a:r>
-              <a:t>Simulation design tests interval behavior</a:t>
+              <a:t>A stress grid separates interval behavior</a:t>
             </a:r>
           </a:p>
         </p:txBody>
@@ -4708,31 +4222,67 @@
               </a:defRPr>
             </a:pPr>
             <a:r>
-              <a:t>DGP knobs flow into two interval methods and one endpoint gate.</a:t>
-            </a:r>
-          </a:p>
-        </p:txBody>
-      </p:sp>
-      <p:sp>
-        <p:nvSpPr>
-          <p:cNvPr id="6" name="Rectangle 5"/>
+              <a:t>The same generated samples feed two intervals and the same coverage endpoint.</a:t>
+            </a:r>
+          </a:p>
+        </p:txBody>
+      </p:sp>
+      <p:sp>
+        <p:nvSpPr>
+          <p:cNvPr id="6" name="TextBox 5"/>
+          <p:cNvSpPr txBox="1"/>
+          <p:nvPr/>
+        </p:nvSpPr>
+        <p:spPr>
+          <a:xfrm>
+            <a:off x="777240" y="1060704"/>
+            <a:ext cx="10515600" cy="256032"/>
+          </a:xfrm>
+          <a:prstGeom prst="rect">
+            <a:avLst/>
+          </a:prstGeom>
+          <a:noFill/>
+        </p:spPr>
+        <p:txBody>
+          <a:bodyPr wrap="square" lIns="36576" rIns="36576" tIns="18288" bIns="18288">
+            <a:spAutoFit/>
+          </a:bodyPr>
+          <a:lstStyle/>
+          <a:p>
+            <a:pPr algn="l">
+              <a:defRPr sz="1180" b="1">
+                <a:solidFill>
+                  <a:srgbClr val="606977"/>
+                </a:solidFill>
+                <a:latin typeface="Aptos"/>
+              </a:defRPr>
+            </a:pPr>
+            <a:r>
+              <a:t>Synthetic experiment: vary center count, ICC, and cluster-size balance.</a:t>
+            </a:r>
+          </a:p>
+        </p:txBody>
+      </p:sp>
+      <p:sp>
+        <p:nvSpPr>
+          <p:cNvPr id="7" name="Rectangle 6"/>
           <p:cNvSpPr/>
           <p:nvPr/>
         </p:nvSpPr>
         <p:spPr>
           <a:xfrm>
-            <a:off x="777240" y="2084831"/>
-            <a:ext cx="2103120" cy="1143000"/>
+            <a:off x="749808" y="1901952"/>
+            <a:ext cx="2331720" cy="1243584"/>
           </a:xfrm>
           <a:prstGeom prst="rect">
             <a:avLst/>
           </a:prstGeom>
           <a:solidFill>
-            <a:srgbClr val="FBF1D6"/>
+            <a:srgbClr val="FFFFFF"/>
           </a:solidFill>
           <a:ln w="12700">
             <a:solidFill>
-              <a:srgbClr val="C6CCD6"/>
+              <a:srgbClr val="9A6A16"/>
             </a:solidFill>
           </a:ln>
         </p:spPr>
@@ -4760,14 +4310,14 @@
       </p:sp>
       <p:sp>
         <p:nvSpPr>
-          <p:cNvPr id="7" name="TextBox 6"/>
+          <p:cNvPr id="8" name="TextBox 7"/>
           <p:cNvSpPr txBox="1"/>
           <p:nvPr/>
         </p:nvSpPr>
         <p:spPr>
           <a:xfrm>
-            <a:off x="832103" y="2130551"/>
-            <a:ext cx="1993391" cy="1051560"/>
+            <a:off x="804671" y="1947672"/>
+            <a:ext cx="2221991" cy="1152144"/>
           </a:xfrm>
           <a:prstGeom prst="rect">
             <a:avLst/>
@@ -4781,9 +4331,9 @@
           <a:lstStyle/>
           <a:p>
             <a:pPr algn="ctr">
-              <a:defRPr sz="1130" b="1">
+              <a:defRPr sz="1180" b="1">
                 <a:solidFill>
-                  <a:srgbClr val="9A6A16"/>
+                  <a:srgbClr val="17202A"/>
                 </a:solidFill>
                 <a:latin typeface="Aptos"/>
               </a:defRPr>
@@ -4793,39 +4343,39 @@
             </a:r>
             <a:br/>
             <a:r>
-              <a:t>G: 8 / 20 / 50</a:t>
+              <a:t>G=8,20,50 centers</a:t>
             </a:r>
             <a:br/>
             <a:r>
-              <a:t>rho: 0 / .1 / .3 / .5</a:t>
+              <a:t>ICC ρ=0,.1,.3,.5</a:t>
             </a:r>
             <a:br/>
             <a:r>
-              <a:t>cluster imbalance</a:t>
-            </a:r>
-          </a:p>
-        </p:txBody>
-      </p:sp>
-      <p:sp>
-        <p:nvSpPr>
-          <p:cNvPr id="8" name="Rectangle 7"/>
+              <a:t>balanced vs imbalanced</a:t>
+            </a:r>
+          </a:p>
+        </p:txBody>
+      </p:sp>
+      <p:sp>
+        <p:nvSpPr>
+          <p:cNvPr id="9" name="Rectangle 8"/>
           <p:cNvSpPr/>
           <p:nvPr/>
         </p:nvSpPr>
         <p:spPr>
           <a:xfrm>
-            <a:off x="3383280" y="2084831"/>
-            <a:ext cx="2057400" cy="1143000"/>
+            <a:off x="3602736" y="1901952"/>
+            <a:ext cx="2331720" cy="1243584"/>
           </a:xfrm>
           <a:prstGeom prst="rect">
             <a:avLst/>
           </a:prstGeom>
           <a:solidFill>
-            <a:srgbClr val="E5EEF8"/>
+            <a:srgbClr val="FFFFFF"/>
           </a:solidFill>
           <a:ln w="12700">
             <a:solidFill>
-              <a:srgbClr val="C6CCD6"/>
+              <a:srgbClr val="1F4E79"/>
             </a:solidFill>
           </a:ln>
         </p:spPr>
@@ -4853,14 +4403,14 @@
       </p:sp>
       <p:sp>
         <p:nvSpPr>
-          <p:cNvPr id="9" name="TextBox 8"/>
+          <p:cNvPr id="10" name="TextBox 9"/>
           <p:cNvSpPr txBox="1"/>
           <p:nvPr/>
         </p:nvSpPr>
         <p:spPr>
           <a:xfrm>
-            <a:off x="3438144" y="2130551"/>
-            <a:ext cx="1947672" cy="1051560"/>
+            <a:off x="3657600" y="1947672"/>
+            <a:ext cx="2221991" cy="1152144"/>
           </a:xfrm>
           <a:prstGeom prst="rect">
             <a:avLst/>
@@ -4874,15 +4424,15 @@
           <a:lstStyle/>
           <a:p>
             <a:pPr algn="ctr">
-              <a:defRPr sz="1130" b="1">
+              <a:defRPr sz="1180" b="1">
                 <a:solidFill>
-                  <a:srgbClr val="1F4E79"/>
+                  <a:srgbClr val="17202A"/>
                 </a:solidFill>
                 <a:latin typeface="Aptos"/>
               </a:defRPr>
             </a:pPr>
             <a:r>
-              <a:t>Monte Carlo data</a:t>
+              <a:t>Generated samples</a:t>
             </a:r>
             <a:br/>
             <a:r>
@@ -4890,31 +4440,31 @@
             </a:r>
             <a:br/>
             <a:r>
-              <a:t>Y_ij, T_ij, center j</a:t>
-            </a:r>
-          </a:p>
-        </p:txBody>
-      </p:sp>
-      <p:sp>
-        <p:nvSpPr>
-          <p:cNvPr id="10" name="Rectangle 9"/>
+              <a:t>outcome, treatment, center</a:t>
+            </a:r>
+          </a:p>
+        </p:txBody>
+      </p:sp>
+      <p:sp>
+        <p:nvSpPr>
+          <p:cNvPr id="11" name="Rectangle 10"/>
           <p:cNvSpPr/>
           <p:nvPr/>
         </p:nvSpPr>
         <p:spPr>
           <a:xfrm>
-            <a:off x="6080760" y="1517904"/>
-            <a:ext cx="2011680" cy="658368"/>
+            <a:off x="6446520" y="1499616"/>
+            <a:ext cx="2157984" cy="530352"/>
           </a:xfrm>
           <a:prstGeom prst="rect">
             <a:avLst/>
           </a:prstGeom>
           <a:solidFill>
-            <a:srgbClr val="F8E3E1"/>
+            <a:srgbClr val="FFFFFF"/>
           </a:solidFill>
           <a:ln w="12700">
             <a:solidFill>
-              <a:srgbClr val="C6CCD6"/>
+              <a:srgbClr val="A33A34"/>
             </a:solidFill>
           </a:ln>
         </p:spPr>
@@ -4942,14 +4492,14 @@
       </p:sp>
       <p:sp>
         <p:nvSpPr>
-          <p:cNvPr id="11" name="TextBox 10"/>
+          <p:cNvPr id="12" name="TextBox 11"/>
           <p:cNvSpPr txBox="1"/>
           <p:nvPr/>
         </p:nvSpPr>
         <p:spPr>
           <a:xfrm>
-            <a:off x="6135624" y="1563624"/>
-            <a:ext cx="1901952" cy="566928"/>
+            <a:off x="6501383" y="1545336"/>
+            <a:ext cx="2048255" cy="438912"/>
           </a:xfrm>
           <a:prstGeom prst="rect">
             <a:avLst/>
@@ -4963,7 +4513,7 @@
           <a:lstStyle/>
           <a:p>
             <a:pPr algn="ctr">
-              <a:defRPr sz="1130" b="1">
+              <a:defRPr sz="1180" b="1">
                 <a:solidFill>
                   <a:srgbClr val="A33A34"/>
                 </a:solidFill>
@@ -4978,24 +4528,24 @@
       </p:sp>
       <p:sp>
         <p:nvSpPr>
-          <p:cNvPr id="12" name="Rectangle 11"/>
+          <p:cNvPr id="13" name="Rectangle 12"/>
           <p:cNvSpPr/>
           <p:nvPr/>
         </p:nvSpPr>
         <p:spPr>
           <a:xfrm>
-            <a:off x="6080760" y="2907792"/>
-            <a:ext cx="2011680" cy="749808"/>
+            <a:off x="6446520" y="2788920"/>
+            <a:ext cx="2157984" cy="713232"/>
           </a:xfrm>
           <a:prstGeom prst="rect">
             <a:avLst/>
           </a:prstGeom>
           <a:solidFill>
-            <a:srgbClr val="E1F4F1"/>
+            <a:srgbClr val="FFFFFF"/>
           </a:solidFill>
           <a:ln w="12700">
             <a:solidFill>
-              <a:srgbClr val="C6CCD6"/>
+              <a:srgbClr val="0F766E"/>
             </a:solidFill>
           </a:ln>
         </p:spPr>
@@ -5023,14 +4573,14 @@
       </p:sp>
       <p:sp>
         <p:nvSpPr>
-          <p:cNvPr id="13" name="TextBox 12"/>
+          <p:cNvPr id="14" name="TextBox 13"/>
           <p:cNvSpPr txBox="1"/>
           <p:nvPr/>
         </p:nvSpPr>
         <p:spPr>
           <a:xfrm>
-            <a:off x="6135624" y="2953512"/>
-            <a:ext cx="1901952" cy="658368"/>
+            <a:off x="6501383" y="2834639"/>
+            <a:ext cx="2048255" cy="621792"/>
           </a:xfrm>
           <a:prstGeom prst="rect">
             <a:avLst/>
@@ -5044,7 +4594,7 @@
           <a:lstStyle/>
           <a:p>
             <a:pPr algn="ctr">
-              <a:defRPr sz="1070" b="1">
+              <a:defRPr sz="1100" b="1">
                 <a:solidFill>
                   <a:srgbClr val="0F766E"/>
                 </a:solidFill>
@@ -5063,24 +4613,24 @@
       </p:sp>
       <p:sp>
         <p:nvSpPr>
-          <p:cNvPr id="14" name="Rectangle 13"/>
+          <p:cNvPr id="15" name="Rectangle 14"/>
           <p:cNvSpPr/>
           <p:nvPr/>
         </p:nvSpPr>
         <p:spPr>
           <a:xfrm>
-            <a:off x="8869680" y="2157984"/>
-            <a:ext cx="2148840" cy="1078992"/>
+            <a:off x="9217152" y="2130552"/>
+            <a:ext cx="2103120" cy="859536"/>
           </a:xfrm>
           <a:prstGeom prst="rect">
             <a:avLst/>
           </a:prstGeom>
           <a:solidFill>
-            <a:srgbClr val="E5EEF8"/>
+            <a:srgbClr val="FFFFFF"/>
           </a:solidFill>
           <a:ln w="12700">
             <a:solidFill>
-              <a:srgbClr val="C6CCD6"/>
+              <a:srgbClr val="4F1F68"/>
             </a:solidFill>
           </a:ln>
         </p:spPr>
@@ -5108,14 +4658,14 @@
       </p:sp>
       <p:sp>
         <p:nvSpPr>
-          <p:cNvPr id="15" name="TextBox 14"/>
+          <p:cNvPr id="16" name="TextBox 15"/>
           <p:cNvSpPr txBox="1"/>
           <p:nvPr/>
         </p:nvSpPr>
         <p:spPr>
           <a:xfrm>
-            <a:off x="8924544" y="2203703"/>
-            <a:ext cx="2039112" cy="987551"/>
+            <a:off x="9272016" y="2176272"/>
+            <a:ext cx="1993391" cy="768096"/>
           </a:xfrm>
           <a:prstGeom prst="rect">
             <a:avLst/>
@@ -5129,63 +4679,19 @@
           <a:lstStyle/>
           <a:p>
             <a:pPr algn="ctr">
-              <a:defRPr sz="1130" b="1">
+              <a:defRPr sz="1180" b="1">
                 <a:solidFill>
-                  <a:srgbClr val="1F4E79"/>
+                  <a:srgbClr val="17202A"/>
                 </a:solidFill>
                 <a:latin typeface="Aptos"/>
               </a:defRPr>
             </a:pPr>
             <a:r>
-              <a:t>Endpoint evaluation</a:t>
-            </a:r>
-            <a:br/>
-            <a:r>
-              <a:t>coverage near 0.95</a:t>
-            </a:r>
-            <a:br/>
-            <a:r>
-              <a:t>bias and interval width</a:t>
-            </a:r>
-          </a:p>
-        </p:txBody>
-      </p:sp>
-      <p:cxnSp>
-        <p:nvCxnSpPr>
-          <p:cNvPr id="16" name="Connector 15"/>
-          <p:cNvCxnSpPr/>
-          <p:nvPr/>
-        </p:nvCxnSpPr>
-        <p:spPr>
-          <a:xfrm>
-            <a:off x="2880360" y="2651760"/>
-            <a:ext cx="484632" cy="0"/>
-          </a:xfrm>
-          <a:prstGeom prst="line">
-            <a:avLst/>
-          </a:prstGeom>
-          <a:ln w="21590">
-            <a:solidFill>
-              <a:srgbClr val="4F1F68"/>
-            </a:solidFill>
-            <a:tailEnd type="triangle"/>
-          </a:ln>
-        </p:spPr>
-        <p:style>
-          <a:lnRef idx="2">
-            <a:schemeClr val="accent1"/>
-          </a:lnRef>
-          <a:fillRef idx="0">
-            <a:schemeClr val="accent1"/>
-          </a:fillRef>
-          <a:effectRef idx="1">
-            <a:schemeClr val="accent1"/>
-          </a:effectRef>
-          <a:fontRef idx="minor">
-            <a:schemeClr val="tx1"/>
-          </a:fontRef>
-        </p:style>
-      </p:cxnSp>
+              <a:t>coverage, bias, interval width</a:t>
+            </a:r>
+          </a:p>
+        </p:txBody>
+      </p:sp>
       <p:cxnSp>
         <p:nvCxnSpPr>
           <p:cNvPr id="17" name="Connector 16"/>
@@ -5193,16 +4699,16 @@
           <p:nvPr/>
         </p:nvCxnSpPr>
         <p:spPr>
-          <a:xfrm flipV="1">
-            <a:off x="5440680" y="1874519"/>
-            <a:ext cx="612648" cy="777241"/>
+          <a:xfrm>
+            <a:off x="3090672" y="2523744"/>
+            <a:ext cx="475488" cy="0"/>
           </a:xfrm>
           <a:prstGeom prst="line">
             <a:avLst/>
           </a:prstGeom>
-          <a:ln w="21590">
+          <a:ln w="20320">
             <a:solidFill>
-              <a:srgbClr val="4F1F68"/>
+              <a:srgbClr val="606977"/>
             </a:solidFill>
             <a:tailEnd type="triangle"/>
           </a:ln>
@@ -5229,16 +4735,16 @@
           <p:nvPr/>
         </p:nvCxnSpPr>
         <p:spPr>
-          <a:xfrm>
-            <a:off x="5440680" y="2651760"/>
-            <a:ext cx="612648" cy="621792"/>
+          <a:xfrm flipV="1">
+            <a:off x="5943600" y="1773936"/>
+            <a:ext cx="475488" cy="749808"/>
           </a:xfrm>
           <a:prstGeom prst="line">
             <a:avLst/>
           </a:prstGeom>
-          <a:ln w="21590">
+          <a:ln w="20320">
             <a:solidFill>
-              <a:srgbClr val="4F1F68"/>
+              <a:srgbClr val="606977"/>
             </a:solidFill>
             <a:tailEnd type="triangle"/>
           </a:ln>
@@ -5266,15 +4772,15 @@
         </p:nvCxnSpPr>
         <p:spPr>
           <a:xfrm>
-            <a:off x="8101583" y="1874519"/>
-            <a:ext cx="749809" cy="612649"/>
+            <a:off x="5943600" y="2523744"/>
+            <a:ext cx="475488" cy="603504"/>
           </a:xfrm>
           <a:prstGeom prst="line">
             <a:avLst/>
           </a:prstGeom>
-          <a:ln w="21590">
+          <a:ln w="20320">
             <a:solidFill>
-              <a:srgbClr val="4F1F68"/>
+              <a:srgbClr val="606977"/>
             </a:solidFill>
             <a:tailEnd type="triangle"/>
           </a:ln>
@@ -5301,16 +4807,16 @@
           <p:nvPr/>
         </p:nvCxnSpPr>
         <p:spPr>
-          <a:xfrm flipV="1">
-            <a:off x="8101583" y="2834640"/>
-            <a:ext cx="749809" cy="438912"/>
+          <a:xfrm>
+            <a:off x="8622792" y="1773936"/>
+            <a:ext cx="566928" cy="621792"/>
           </a:xfrm>
           <a:prstGeom prst="line">
             <a:avLst/>
           </a:prstGeom>
-          <a:ln w="21590">
+          <a:ln w="20320">
             <a:solidFill>
-              <a:srgbClr val="4F1F68"/>
+              <a:srgbClr val="606977"/>
             </a:solidFill>
             <a:tailEnd type="triangle"/>
           </a:ln>
@@ -5330,16 +4836,87 @@
           </a:fontRef>
         </p:style>
       </p:cxnSp>
-      <p:sp>
-        <p:nvSpPr>
-          <p:cNvPr id="21" name="TextBox 20"/>
+      <p:cxnSp>
+        <p:nvCxnSpPr>
+          <p:cNvPr id="21" name="Connector 20"/>
+          <p:cNvCxnSpPr/>
+          <p:nvPr/>
+        </p:nvCxnSpPr>
+        <p:spPr>
+          <a:xfrm flipV="1">
+            <a:off x="8622792" y="2724912"/>
+            <a:ext cx="566928" cy="402336"/>
+          </a:xfrm>
+          <a:prstGeom prst="line">
+            <a:avLst/>
+          </a:prstGeom>
+          <a:ln w="20320">
+            <a:solidFill>
+              <a:srgbClr val="606977"/>
+            </a:solidFill>
+            <a:tailEnd type="triangle"/>
+          </a:ln>
+        </p:spPr>
+        <p:style>
+          <a:lnRef idx="2">
+            <a:schemeClr val="accent1"/>
+          </a:lnRef>
+          <a:fillRef idx="0">
+            <a:schemeClr val="accent1"/>
+          </a:fillRef>
+          <a:effectRef idx="1">
+            <a:schemeClr val="accent1"/>
+          </a:effectRef>
+          <a:fontRef idx="minor">
+            <a:schemeClr val="tx1"/>
+          </a:fontRef>
+        </p:style>
+      </p:cxnSp>
+      <p:cxnSp>
+        <p:nvCxnSpPr>
+          <p:cNvPr id="22" name="Connector 21"/>
+          <p:cNvCxnSpPr/>
+          <p:nvPr/>
+        </p:nvCxnSpPr>
+        <p:spPr>
+          <a:xfrm>
+            <a:off x="868680" y="4407408"/>
+            <a:ext cx="9966960" cy="0"/>
+          </a:xfrm>
+          <a:prstGeom prst="line">
+            <a:avLst/>
+          </a:prstGeom>
+          <a:ln w="12700">
+            <a:solidFill>
+              <a:srgbClr val="C6CCD6"/>
+            </a:solidFill>
+          </a:ln>
+        </p:spPr>
+        <p:style>
+          <a:lnRef idx="2">
+            <a:schemeClr val="accent1"/>
+          </a:lnRef>
+          <a:fillRef idx="0">
+            <a:schemeClr val="accent1"/>
+          </a:fillRef>
+          <a:effectRef idx="1">
+            <a:schemeClr val="accent1"/>
+          </a:effectRef>
+          <a:fontRef idx="minor">
+            <a:schemeClr val="tx1"/>
+          </a:fontRef>
+        </p:style>
+      </p:cxnSp>
+      <p:sp>
+        <p:nvSpPr>
+          <p:cNvPr id="23" name="TextBox 22"/>
           <p:cNvSpPr txBox="1"/>
           <p:nvPr/>
         </p:nvSpPr>
         <p:spPr>
           <a:xfrm>
-            <a:off x="868680" y="4480560"/>
-            <a:ext cx="10149840" cy="310896"/>
+            <a:off x="914400" y="4736592"/>
+            <a:ext cx="9875520" cy="438912"/>
           </a:xfrm>
           <a:prstGeom prst="rect">
             <a:avLst/>
@@ -5353,7 +4930,7 @@
           <a:lstStyle/>
           <a:p>
             <a:pPr algn="l">
-              <a:defRPr sz="1260" b="1">
+              <a:defRPr sz="1400" b="1">
                 <a:solidFill>
                   <a:srgbClr val="17202A"/>
                 </a:solidFill>
@@ -5361,21 +4938,21 @@
               </a:defRPr>
             </a:pPr>
             <a:r>
-              <a:t>Diagram contract: structural connectors, visible arrowheads, left-to-right reading, no edge crossing.</a:t>
-            </a:r>
-          </a:p>
-        </p:txBody>
-      </p:sp>
-      <p:sp>
-        <p:nvSpPr>
-          <p:cNvPr id="22" name="TextBox 21"/>
+              <a:t>The design asks whether center aggregation repairs interval coverage across the stress grid.</a:t>
+            </a:r>
+          </a:p>
+        </p:txBody>
+      </p:sp>
+      <p:sp>
+        <p:nvSpPr>
+          <p:cNvPr id="24" name="TextBox 23"/>
           <p:cNvSpPr txBox="1"/>
           <p:nvPr/>
         </p:nvSpPr>
         <p:spPr>
           <a:xfrm>
-            <a:off x="868680" y="4983480"/>
-            <a:ext cx="10149840" cy="274320"/>
+            <a:off x="914400" y="5340096"/>
+            <a:ext cx="9875520" cy="292608"/>
           </a:xfrm>
           <a:prstGeom prst="rect">
             <a:avLst/>
@@ -5389,43 +4966,7 @@
           <a:lstStyle/>
           <a:p>
             <a:pPr algn="l">
-              <a:defRPr sz="1110" b="1">
-                <a:solidFill>
-                  <a:srgbClr val="9A6A16"/>
-                </a:solidFill>
-                <a:latin typeface="Aptos"/>
-              </a:defRPr>
-            </a:pPr>
-            <a:r>
-              <a:t>Synthetic simulation evidence boundary: this experiment distinguishes interval behavior; it is not a general theorem.</a:t>
-            </a:r>
-          </a:p>
-        </p:txBody>
-      </p:sp>
-      <p:sp>
-        <p:nvSpPr>
-          <p:cNvPr id="23" name="TextBox 22"/>
-          <p:cNvSpPr txBox="1"/>
-          <p:nvPr/>
-        </p:nvSpPr>
-        <p:spPr>
-          <a:xfrm>
-            <a:off x="868680" y="5989320"/>
-            <a:ext cx="10241280" cy="320040"/>
-          </a:xfrm>
-          <a:prstGeom prst="rect">
-            <a:avLst/>
-          </a:prstGeom>
-          <a:noFill/>
-        </p:spPr>
-        <p:txBody>
-          <a:bodyPr wrap="square" lIns="36576" rIns="36576" tIns="18288" bIns="18288">
-            <a:spAutoFit/>
-          </a:bodyPr>
-          <a:lstStyle/>
-          <a:p>
-            <a:pPr algn="l">
-              <a:defRPr sz="840" b="0">
+              <a:defRPr sz="1150" b="0">
                 <a:solidFill>
                   <a:srgbClr val="606977"/>
                 </a:solidFill>
@@ -5433,7 +4974,7 @@
               </a:defRPr>
             </a:pPr>
             <a:r>
-              <a:t>Reference retrieval: simulation-design query selected inspected pages RRL-009, RRL-010, RRL-019, RRL-026, RRL-002; trace in EVIDENCE_MANIFEST; style not copied.</a:t>
+              <a:t>Simulation study; endpoints are computed from the deterministic output for the same DGP grid.</a:t>
             </a:r>
           </a:p>
         </p:txBody>
@@ -5452,7 +4993,7 @@
     <p:bg>
       <p:bgPr>
         <a:solidFill>
-          <a:srgbClr val="F7F7F9"/>
+          <a:srgbClr val="F1F2F4"/>
         </a:solidFill>
         <a:effectLst/>
       </p:bgPr>
@@ -5538,7 +5079,7 @@
               </a:defRPr>
             </a:pPr>
             <a:r>
-              <a:t>Coverage falls when ICC and imbalance rise</a:t>
+              <a:t>Cluster adjustment recovers coverage except at small G</a:t>
             </a:r>
           </a:p>
         </p:txBody>
@@ -5610,7 +5151,7 @@
               </a:defRPr>
             </a:pPr>
             <a:r>
-              <a:t>Coverage near 0.95 is the target; uncertainty must be visible.</a:t>
+              <a:t>Coverage near 0.95 is the target; uncertainty is part of the figure.</a:t>
             </a:r>
           </a:p>
         </p:txBody>
@@ -5631,8 +5172,8 @@
         </p:blipFill>
         <p:spPr>
           <a:xfrm>
-            <a:off x="502920" y="1170432"/>
-            <a:ext cx="7909560" cy="4088840"/>
+            <a:off x="749808" y="1170432"/>
+            <a:ext cx="9966960" cy="4714103"/>
           </a:xfrm>
           <a:prstGeom prst="rect">
             <a:avLst/>
@@ -5641,59 +5182,14 @@
       </p:pic>
       <p:sp>
         <p:nvSpPr>
-          <p:cNvPr id="7" name="Rectangle 6"/>
-          <p:cNvSpPr/>
-          <p:nvPr/>
-        </p:nvSpPr>
-        <p:spPr>
-          <a:xfrm>
-            <a:off x="8732520" y="1325880"/>
-            <a:ext cx="2651760" cy="1078992"/>
-          </a:xfrm>
-          <a:prstGeom prst="rect">
-            <a:avLst/>
-          </a:prstGeom>
-          <a:solidFill>
-            <a:srgbClr val="FBF1D6"/>
-          </a:solidFill>
-          <a:ln w="12700">
-            <a:solidFill>
-              <a:srgbClr val="C6CCD6"/>
-            </a:solidFill>
-          </a:ln>
-        </p:spPr>
-        <p:style>
-          <a:lnRef idx="1">
-            <a:schemeClr val="accent1"/>
-          </a:lnRef>
-          <a:fillRef idx="3">
-            <a:schemeClr val="accent1"/>
-          </a:fillRef>
-          <a:effectRef idx="2">
-            <a:schemeClr val="accent1"/>
-          </a:effectRef>
-          <a:fontRef idx="minor">
-            <a:schemeClr val="lt1"/>
-          </a:fontRef>
-        </p:style>
-        <p:txBody>
-          <a:bodyPr rtlCol="0" anchor="ctr"/>
-          <a:lstStyle/>
-          <a:p>
-            <a:pPr algn="ctr"/>
-          </a:p>
-        </p:txBody>
-      </p:sp>
-      <p:sp>
-        <p:nvSpPr>
-          <p:cNvPr id="8" name="TextBox 7"/>
+          <p:cNvPr id="7" name="TextBox 6"/>
           <p:cNvSpPr txBox="1"/>
           <p:nvPr/>
         </p:nvSpPr>
         <p:spPr>
           <a:xfrm>
-            <a:off x="8787384" y="1371600"/>
-            <a:ext cx="2542032" cy="987551"/>
+            <a:off x="868680" y="5870448"/>
+            <a:ext cx="8138160" cy="256032"/>
           </a:xfrm>
           <a:prstGeom prst="rect">
             <a:avLst/>
@@ -5706,217 +5202,8 @@
           </a:bodyPr>
           <a:lstStyle/>
           <a:p>
-            <a:pPr algn="ctr">
-              <a:defRPr sz="1140" b="1">
-                <a:solidFill>
-                  <a:srgbClr val="9A6A16"/>
-                </a:solidFill>
-                <a:latin typeface="Aptos"/>
-              </a:defRPr>
-            </a:pPr>
-            <a:r>
-              <a:t>Reading target</a:t>
-            </a:r>
-            <a:br/>
-            <a:r>
-              <a:t>Coverage close to nominal 0.95 is the goal.</a:t>
-            </a:r>
-            <a:br/>
-            <a:r>
-              <a:t>Above or below nominal is not automatically better.</a:t>
-            </a:r>
-          </a:p>
-        </p:txBody>
-      </p:sp>
-      <p:sp>
-        <p:nvSpPr>
-          <p:cNvPr id="9" name="Rectangle 8"/>
-          <p:cNvSpPr/>
-          <p:nvPr/>
-        </p:nvSpPr>
-        <p:spPr>
-          <a:xfrm>
-            <a:off x="8732520" y="2788920"/>
-            <a:ext cx="2651760" cy="1261872"/>
-          </a:xfrm>
-          <a:prstGeom prst="rect">
-            <a:avLst/>
-          </a:prstGeom>
-          <a:solidFill>
-            <a:srgbClr val="E1F4F1"/>
-          </a:solidFill>
-          <a:ln w="12700">
-            <a:solidFill>
-              <a:srgbClr val="C6CCD6"/>
-            </a:solidFill>
-          </a:ln>
-        </p:spPr>
-        <p:style>
-          <a:lnRef idx="1">
-            <a:schemeClr val="accent1"/>
-          </a:lnRef>
-          <a:fillRef idx="3">
-            <a:schemeClr val="accent1"/>
-          </a:fillRef>
-          <a:effectRef idx="2">
-            <a:schemeClr val="accent1"/>
-          </a:effectRef>
-          <a:fontRef idx="minor">
-            <a:schemeClr val="lt1"/>
-          </a:fontRef>
-        </p:style>
-        <p:txBody>
-          <a:bodyPr rtlCol="0" anchor="ctr"/>
-          <a:lstStyle/>
-          <a:p>
-            <a:pPr algn="ctr"/>
-          </a:p>
-        </p:txBody>
-      </p:sp>
-      <p:sp>
-        <p:nvSpPr>
-          <p:cNvPr id="10" name="TextBox 9"/>
-          <p:cNvSpPr txBox="1"/>
-          <p:nvPr/>
-        </p:nvSpPr>
-        <p:spPr>
-          <a:xfrm>
-            <a:off x="8787384" y="2834639"/>
-            <a:ext cx="2542032" cy="1170431"/>
-          </a:xfrm>
-          <a:prstGeom prst="rect">
-            <a:avLst/>
-          </a:prstGeom>
-          <a:noFill/>
-        </p:spPr>
-        <p:txBody>
-          <a:bodyPr wrap="square" lIns="36576" rIns="36576" tIns="18288" bIns="18288">
-            <a:spAutoFit/>
-          </a:bodyPr>
-          <a:lstStyle/>
-          <a:p>
-            <a:pPr algn="ctr">
-              <a:defRPr sz="1140" b="1">
-                <a:solidFill>
-                  <a:srgbClr val="0F766E"/>
-                </a:solidFill>
-                <a:latin typeface="Aptos"/>
-              </a:defRPr>
-            </a:pPr>
-            <a:r>
-              <a:t>Observed in this synthetic run</a:t>
-            </a:r>
-            <a:br/>
-            <a:r>
-              <a:t>G=8, rho=.5, imbalanced:</a:t>
-            </a:r>
-            <a:br/>
-            <a:r>
-              <a:t>naive=0.52</a:t>
-            </a:r>
-            <a:br/>
-            <a:r>
-              <a:t>cluster=0.78</a:t>
-            </a:r>
-          </a:p>
-        </p:txBody>
-      </p:sp>
-      <p:sp>
-        <p:nvSpPr>
-          <p:cNvPr id="11" name="TextBox 10"/>
-          <p:cNvSpPr txBox="1"/>
-          <p:nvPr/>
-        </p:nvSpPr>
-        <p:spPr>
-          <a:xfrm>
-            <a:off x="868680" y="5276088"/>
-            <a:ext cx="10058400" cy="347472"/>
-          </a:xfrm>
-          <a:prstGeom prst="rect">
-            <a:avLst/>
-          </a:prstGeom>
-          <a:noFill/>
-        </p:spPr>
-        <p:txBody>
-          <a:bodyPr wrap="square" lIns="36576" rIns="36576" tIns="18288" bIns="18288">
-            <a:spAutoFit/>
-          </a:bodyPr>
-          <a:lstStyle/>
-          <a:p>
             <a:pPr algn="l">
-              <a:defRPr sz="1280" b="1">
-                <a:solidFill>
-                  <a:srgbClr val="17202A"/>
-                </a:solidFill>
-                <a:latin typeface="Aptos"/>
-              </a:defRPr>
-            </a:pPr>
-            <a:r>
-              <a:t>Conclusion limited to this simulation: cluster-robust intervals repair much of the iid undercoverage, but finite-center stress remains visible.</a:t>
-            </a:r>
-          </a:p>
-        </p:txBody>
-      </p:sp>
-      <p:sp>
-        <p:nvSpPr>
-          <p:cNvPr id="12" name="TextBox 11"/>
-          <p:cNvSpPr txBox="1"/>
-          <p:nvPr/>
-        </p:nvSpPr>
-        <p:spPr>
-          <a:xfrm>
-            <a:off x="868680" y="5687568"/>
-            <a:ext cx="10058400" cy="256032"/>
-          </a:xfrm>
-          <a:prstGeom prst="rect">
-            <a:avLst/>
-          </a:prstGeom>
-          <a:noFill/>
-        </p:spPr>
-        <p:txBody>
-          <a:bodyPr wrap="square" lIns="36576" rIns="36576" tIns="18288" bIns="18288">
-            <a:spAutoFit/>
-          </a:bodyPr>
-          <a:lstStyle/>
-          <a:p>
-            <a:pPr algn="l">
-              <a:defRPr sz="1060" b="1">
-                <a:solidFill>
-                  <a:srgbClr val="9A6A16"/>
-                </a:solidFill>
-                <a:latin typeface="Aptos"/>
-              </a:defRPr>
-            </a:pPr>
-            <a:r>
-              <a:t>Synthetic simulation evidence boundary; error bars are Monte Carlo uncertainty from deterministic simulation output.</a:t>
-            </a:r>
-          </a:p>
-        </p:txBody>
-      </p:sp>
-      <p:sp>
-        <p:nvSpPr>
-          <p:cNvPr id="13" name="TextBox 12"/>
-          <p:cNvSpPr txBox="1"/>
-          <p:nvPr/>
-        </p:nvSpPr>
-        <p:spPr>
-          <a:xfrm>
-            <a:off x="868680" y="6053328"/>
-            <a:ext cx="10241280" cy="256032"/>
-          </a:xfrm>
-          <a:prstGeom prst="rect">
-            <a:avLst/>
-          </a:prstGeom>
-          <a:noFill/>
-        </p:spPr>
-        <p:txBody>
-          <a:bodyPr wrap="square" lIns="36576" rIns="36576" tIns="18288" bIns="18288">
-            <a:spAutoFit/>
-          </a:bodyPr>
-          <a:lstStyle/>
-          <a:p>
-            <a:pPr algn="l">
-              <a:defRPr sz="840" b="0">
+              <a:defRPr sz="1050" b="0">
                 <a:solidFill>
                   <a:srgbClr val="606977"/>
                 </a:solidFill>
@@ -5924,7 +5211,7 @@
               </a:defRPr>
             </a:pPr>
             <a:r>
-              <a:t>Reference retrieval: coverage-result query selected inspected pages RRL-030, RRL-033, RRL-010, RRL-023, RRL-039; trace in EVIDENCE_MANIFEST; style not copied.</a:t>
+              <a:t>Synthetic imbalanced-cluster simulation; bands show Monte Carlo uncertainty.</a:t>
             </a:r>
           </a:p>
         </p:txBody>
@@ -5943,7 +5230,7 @@
     <p:bg>
       <p:bgPr>
         <a:solidFill>
-          <a:srgbClr val="F7F7F9"/>
+          <a:srgbClr val="F1F2F4"/>
         </a:solidFill>
         <a:effectLst/>
       </p:bgPr>
@@ -6029,7 +5316,7 @@
               </a:defRPr>
             </a:pPr>
             <a:r>
-              <a:t>Small-G stress remains the negative result</a:t>
+              <a:t>The remaining failure is finite-center undercoverage</a:t>
             </a:r>
           </a:p>
         </p:txBody>
@@ -6101,7 +5388,7 @@
               </a:defRPr>
             </a:pPr>
             <a:r>
-              <a:t>The next experiment must test finite-center corrections.</a:t>
+              <a:t>The next experiment tests small-sample corrections under the same grid.</a:t>
             </a:r>
           </a:p>
         </p:txBody>
@@ -6122,8 +5409,8 @@
         </p:blipFill>
         <p:spPr>
           <a:xfrm>
-            <a:off x="685800" y="1261872"/>
-            <a:ext cx="6126480" cy="2688149"/>
+            <a:off x="530352" y="1261872"/>
+            <a:ext cx="7589520" cy="3344534"/>
           </a:xfrm>
           <a:prstGeom prst="rect">
             <a:avLst/>
@@ -6132,59 +5419,14 @@
       </p:pic>
       <p:sp>
         <p:nvSpPr>
-          <p:cNvPr id="7" name="Rectangle 6"/>
-          <p:cNvSpPr/>
-          <p:nvPr/>
-        </p:nvSpPr>
-        <p:spPr>
-          <a:xfrm>
-            <a:off x="7315200" y="1353312"/>
-            <a:ext cx="3246120" cy="1078992"/>
-          </a:xfrm>
-          <a:prstGeom prst="rect">
-            <a:avLst/>
-          </a:prstGeom>
-          <a:solidFill>
-            <a:srgbClr val="F8E3E1"/>
-          </a:solidFill>
-          <a:ln w="12700">
-            <a:solidFill>
-              <a:srgbClr val="C6CCD6"/>
-            </a:solidFill>
-          </a:ln>
-        </p:spPr>
-        <p:style>
-          <a:lnRef idx="1">
-            <a:schemeClr val="accent1"/>
-          </a:lnRef>
-          <a:fillRef idx="3">
-            <a:schemeClr val="accent1"/>
-          </a:fillRef>
-          <a:effectRef idx="2">
-            <a:schemeClr val="accent1"/>
-          </a:effectRef>
-          <a:fontRef idx="minor">
-            <a:schemeClr val="lt1"/>
-          </a:fontRef>
-        </p:style>
-        <p:txBody>
-          <a:bodyPr rtlCol="0" anchor="ctr"/>
-          <a:lstStyle/>
-          <a:p>
-            <a:pPr algn="ctr"/>
-          </a:p>
-        </p:txBody>
-      </p:sp>
-      <p:sp>
-        <p:nvSpPr>
-          <p:cNvPr id="8" name="TextBox 7"/>
+          <p:cNvPr id="7" name="TextBox 6"/>
           <p:cNvSpPr txBox="1"/>
           <p:nvPr/>
         </p:nvSpPr>
         <p:spPr>
           <a:xfrm>
-            <a:off x="7370064" y="1399032"/>
-            <a:ext cx="3136391" cy="987551"/>
+            <a:off x="8458200" y="1417320"/>
+            <a:ext cx="2514600" cy="731520"/>
           </a:xfrm>
           <a:prstGeom prst="rect">
             <a:avLst/>
@@ -6197,8 +5439,8 @@
           </a:bodyPr>
           <a:lstStyle/>
           <a:p>
-            <a:pPr algn="ctr">
-              <a:defRPr sz="1170" b="1">
+            <a:pPr algn="l">
+              <a:defRPr sz="1300" b="1">
                 <a:solidFill>
                   <a:srgbClr val="A33A34"/>
                 </a:solidFill>
@@ -6206,36 +5448,25 @@
               </a:defRPr>
             </a:pPr>
             <a:r>
-              <a:t>Negative result</a:t>
-            </a:r>
-            <a:br/>
-            <a:r>
-              <a:t>G=8, rho=0.5, imbalanced cluster sizes and treatment shares</a:t>
-            </a:r>
-            <a:br/>
-            <a:r>
-              <a:t>cluster-robust z coverage = 0.78</a:t>
-            </a:r>
-          </a:p>
-        </p:txBody>
-      </p:sp>
-      <p:sp>
-        <p:nvSpPr>
-          <p:cNvPr id="9" name="Rectangle 8"/>
-          <p:cNvSpPr/>
-          <p:nvPr/>
-        </p:nvSpPr>
-        <p:spPr>
-          <a:xfrm>
-            <a:off x="7315200" y="2788920"/>
-            <a:ext cx="3246120" cy="1005840"/>
-          </a:xfrm>
-          <a:prstGeom prst="rect">
-            <a:avLst/>
-          </a:prstGeom>
-          <a:solidFill>
-            <a:srgbClr val="FBF1D6"/>
-          </a:solidFill>
+              <a:t>At G=8, ICC ρ=.5, imbalanced clusters, cluster-robust coverage is 0.78.</a:t>
+            </a:r>
+          </a:p>
+        </p:txBody>
+      </p:sp>
+      <p:cxnSp>
+        <p:nvCxnSpPr>
+          <p:cNvPr id="8" name="Connector 7"/>
+          <p:cNvCxnSpPr/>
+          <p:nvPr/>
+        </p:nvCxnSpPr>
+        <p:spPr>
+          <a:xfrm>
+            <a:off x="8458200" y="2359152"/>
+            <a:ext cx="2377440" cy="0"/>
+          </a:xfrm>
+          <a:prstGeom prst="line">
+            <a:avLst/>
+          </a:prstGeom>
           <a:ln w="12700">
             <a:solidFill>
               <a:srgbClr val="C6CCD6"/>
@@ -6243,37 +5474,30 @@
           </a:ln>
         </p:spPr>
         <p:style>
-          <a:lnRef idx="1">
+          <a:lnRef idx="2">
             <a:schemeClr val="accent1"/>
           </a:lnRef>
-          <a:fillRef idx="3">
+          <a:fillRef idx="0">
             <a:schemeClr val="accent1"/>
           </a:fillRef>
-          <a:effectRef idx="2">
+          <a:effectRef idx="1">
             <a:schemeClr val="accent1"/>
           </a:effectRef>
           <a:fontRef idx="minor">
-            <a:schemeClr val="lt1"/>
+            <a:schemeClr val="tx1"/>
           </a:fontRef>
         </p:style>
-        <p:txBody>
-          <a:bodyPr rtlCol="0" anchor="ctr"/>
-          <a:lstStyle/>
-          <a:p>
-            <a:pPr algn="ctr"/>
-          </a:p>
-        </p:txBody>
-      </p:sp>
-      <p:sp>
-        <p:nvSpPr>
-          <p:cNvPr id="10" name="TextBox 9"/>
+      </p:cxnSp>
+      <p:sp>
+        <p:nvSpPr>
+          <p:cNvPr id="9" name="TextBox 8"/>
           <p:cNvSpPr txBox="1"/>
           <p:nvPr/>
         </p:nvSpPr>
         <p:spPr>
           <a:xfrm>
-            <a:off x="7370064" y="2834639"/>
-            <a:ext cx="3136391" cy="914400"/>
+            <a:off x="8458200" y="2615184"/>
+            <a:ext cx="2651760" cy="658368"/>
           </a:xfrm>
           <a:prstGeom prst="rect">
             <a:avLst/>
@@ -6286,41 +5510,34 @@
           </a:bodyPr>
           <a:lstStyle/>
           <a:p>
-            <a:pPr algn="ctr">
-              <a:defRPr sz="1140" b="1">
+            <a:pPr algn="l">
+              <a:defRPr sz="1210" b="1">
                 <a:solidFill>
-                  <a:srgbClr val="9A6A16"/>
+                  <a:srgbClr val="17202A"/>
                 </a:solidFill>
                 <a:latin typeface="Aptos"/>
               </a:defRPr>
             </a:pPr>
             <a:r>
-              <a:t>Failure mechanism</a:t>
-            </a:r>
-            <a:br/>
-            <a:r>
-              <a:t>Few independent centers make the sandwich variance noisy; imbalance amplifies center-level leverage.</a:t>
-            </a:r>
-          </a:p>
-        </p:txBody>
-      </p:sp>
-      <p:sp>
-        <p:nvSpPr>
-          <p:cNvPr id="11" name="Rectangle 10"/>
-          <p:cNvSpPr/>
-          <p:nvPr/>
-        </p:nvSpPr>
-        <p:spPr>
-          <a:xfrm>
-            <a:off x="7315200" y="4169663"/>
-            <a:ext cx="3246120" cy="1097280"/>
-          </a:xfrm>
-          <a:prstGeom prst="rect">
-            <a:avLst/>
-          </a:prstGeom>
-          <a:solidFill>
-            <a:srgbClr val="E1F4F1"/>
-          </a:solidFill>
+              <a:t>Few centers make the sandwich variance noisy; imbalance increases center leverage.</a:t>
+            </a:r>
+          </a:p>
+        </p:txBody>
+      </p:sp>
+      <p:cxnSp>
+        <p:nvCxnSpPr>
+          <p:cNvPr id="10" name="Connector 9"/>
+          <p:cNvCxnSpPr/>
+          <p:nvPr/>
+        </p:nvCxnSpPr>
+        <p:spPr>
+          <a:xfrm>
+            <a:off x="8458200" y="3493008"/>
+            <a:ext cx="2377440" cy="0"/>
+          </a:xfrm>
+          <a:prstGeom prst="line">
+            <a:avLst/>
+          </a:prstGeom>
           <a:ln w="12700">
             <a:solidFill>
               <a:srgbClr val="C6CCD6"/>
@@ -6328,37 +5545,30 @@
           </a:ln>
         </p:spPr>
         <p:style>
-          <a:lnRef idx="1">
+          <a:lnRef idx="2">
             <a:schemeClr val="accent1"/>
           </a:lnRef>
-          <a:fillRef idx="3">
+          <a:fillRef idx="0">
             <a:schemeClr val="accent1"/>
           </a:fillRef>
-          <a:effectRef idx="2">
+          <a:effectRef idx="1">
             <a:schemeClr val="accent1"/>
           </a:effectRef>
           <a:fontRef idx="minor">
-            <a:schemeClr val="lt1"/>
+            <a:schemeClr val="tx1"/>
           </a:fontRef>
         </p:style>
-        <p:txBody>
-          <a:bodyPr rtlCol="0" anchor="ctr"/>
-          <a:lstStyle/>
-          <a:p>
-            <a:pPr algn="ctr"/>
-          </a:p>
-        </p:txBody>
-      </p:sp>
-      <p:sp>
-        <p:nvSpPr>
-          <p:cNvPr id="12" name="TextBox 11"/>
+      </p:cxnSp>
+      <p:sp>
+        <p:nvSpPr>
+          <p:cNvPr id="11" name="TextBox 10"/>
           <p:cNvSpPr txBox="1"/>
           <p:nvPr/>
         </p:nvSpPr>
         <p:spPr>
           <a:xfrm>
-            <a:off x="7370064" y="4215383"/>
-            <a:ext cx="3136391" cy="1005839"/>
+            <a:off x="8458200" y="3749039"/>
+            <a:ext cx="2651760" cy="786384"/>
           </a:xfrm>
           <a:prstGeom prst="rect">
             <a:avLst/>
@@ -6371,8 +5581,8 @@
           </a:bodyPr>
           <a:lstStyle/>
           <a:p>
-            <a:pPr algn="ctr">
-              <a:defRPr sz="1120" b="1">
+            <a:pPr algn="l">
+              <a:defRPr sz="1180" b="1">
                 <a:solidFill>
                   <a:srgbClr val="0F766E"/>
                 </a:solidFill>
@@ -6380,25 +5590,21 @@
               </a:defRPr>
             </a:pPr>
             <a:r>
-              <a:t>Next experiment is planned, not completed</a:t>
-            </a:r>
-            <a:br/>
-            <a:r>
-              <a:t>Compare CR2 small-sample correction and wild cluster bootstrap on the same grid.</a:t>
-            </a:r>
-          </a:p>
-        </p:txBody>
-      </p:sp>
-      <p:sp>
-        <p:nvSpPr>
-          <p:cNvPr id="13" name="TextBox 12"/>
+              <a:t>Planned comparison: CR2 small-sample correction and wild cluster bootstrap on the same grid.</a:t>
+            </a:r>
+          </a:p>
+        </p:txBody>
+      </p:sp>
+      <p:sp>
+        <p:nvSpPr>
+          <p:cNvPr id="12" name="TextBox 11"/>
           <p:cNvSpPr txBox="1"/>
           <p:nvPr/>
         </p:nvSpPr>
         <p:spPr>
           <a:xfrm>
-            <a:off x="868680" y="5577840"/>
-            <a:ext cx="10149840" cy="320040"/>
+            <a:off x="868680" y="5669280"/>
+            <a:ext cx="10149840" cy="292608"/>
           </a:xfrm>
           <a:prstGeom prst="rect">
             <a:avLst/>
@@ -6412,43 +5618,7 @@
           <a:lstStyle/>
           <a:p>
             <a:pPr algn="l">
-              <a:defRPr sz="1220" b="1">
-                <a:solidFill>
-                  <a:srgbClr val="17202A"/>
-                </a:solidFill>
-                <a:latin typeface="Aptos"/>
-              </a:defRPr>
-            </a:pPr>
-            <a:r>
-              <a:t>This page uses completed synthetic evidence only for the failure diagnosis; the proposed correction methods are explicitly future work.</a:t>
-            </a:r>
-          </a:p>
-        </p:txBody>
-      </p:sp>
-      <p:sp>
-        <p:nvSpPr>
-          <p:cNvPr id="14" name="TextBox 13"/>
-          <p:cNvSpPr txBox="1"/>
-          <p:nvPr/>
-        </p:nvSpPr>
-        <p:spPr>
-          <a:xfrm>
-            <a:off x="868680" y="6053328"/>
-            <a:ext cx="10241280" cy="256032"/>
-          </a:xfrm>
-          <a:prstGeom prst="rect">
-            <a:avLst/>
-          </a:prstGeom>
-          <a:noFill/>
-        </p:spPr>
-        <p:txBody>
-          <a:bodyPr wrap="square" lIns="36576" rIns="36576" tIns="18288" bIns="18288">
-            <a:spAutoFit/>
-          </a:bodyPr>
-          <a:lstStyle/>
-          <a:p>
-            <a:pPr algn="l">
-              <a:defRPr sz="840" b="0">
+              <a:defRPr sz="1180" b="0">
                 <a:solidFill>
                   <a:srgbClr val="606977"/>
                 </a:solidFill>
@@ -6456,7 +5626,7 @@
               </a:defRPr>
             </a:pPr>
             <a:r>
-              <a:t>Reference retrieval: negative-result query selected inspected pages RRL-011, RRL-024, RRL-025, RRL-041, RRL-005; trace in EVIDENCE_MANIFEST; style not copied.</a:t>
+              <a:t>Completed evidence is limited to the two intervals shown; the correction methods are future tests.</a:t>
             </a:r>
           </a:p>
         </p:txBody>

</xml_diff>

<commit_message>
Address 016 Terra evidence findings
</commit_message>
<xml_diff>
--- a/tests/fixtures/presentations/statistical_method_group_meeting/visual_review_packet_source/statistical_method_group_meeting_benchmark.pptx
+++ b/tests/fixtures/presentations/statistical_method_group_meeting/visual_review_packet_source/statistical_method_group_meeting_benchmark.pptx
@@ -5079,7 +5079,7 @@
               </a:defRPr>
             </a:pPr>
             <a:r>
-              <a:t>Cluster adjustment recovers coverage except at small G</a:t>
+              <a:t>Cluster adjustment reduces, but does not erase, undercoverage</a:t>
             </a:r>
           </a:p>
         </p:txBody>
@@ -5151,7 +5151,7 @@
               </a:defRPr>
             </a:pPr>
             <a:r>
-              <a:t>Coverage near 0.95 is the target; uncertainty is part of the figure.</a:t>
+              <a:t>Coverage near 0.95 is the target; Monte Carlo error bars are part of the evidence.</a:t>
             </a:r>
           </a:p>
         </p:txBody>
@@ -5211,7 +5211,7 @@
               </a:defRPr>
             </a:pPr>
             <a:r>
-              <a:t>Synthetic imbalanced-cluster simulation; bands show Monte Carlo uncertainty.</a:t>
+              <a:t>Synthetic imbalanced-cluster simulation; vertical marks show Monte Carlo error bars.</a:t>
             </a:r>
           </a:p>
         </p:txBody>
@@ -5626,7 +5626,7 @@
               </a:defRPr>
             </a:pPr>
             <a:r>
-              <a:t>Completed evidence is limited to the two intervals shown; the correction methods are future tests.</a:t>
+              <a:t>Completed evidence is limited to the two intervals shown; bar intervals show Monte Carlo error bars.</a:t>
             </a:r>
           </a:p>
         </p:txBody>

</xml_diff>